<commit_message>
Sync the investor kit with the full defect inventory
WHITEPAPER.md §8 listed three integrity bugs. Nine were actually fixed across
the last three passes, and four of those were on the money path or on the audit
trail that records it. Shipping the shorter list would have understated our own
work in the one section whose whole purpose is not understating anything.

Slide 7 gained the money-path card in the empty left column, so the deck tells
the same story as the paper. Counts elsewhere (87 tests, 10,584 lines) were
stale against the tree and now match it.
</commit_message>
<xml_diff>
--- a/docs/investors/KAIROS_Investor_Deck.pptx
+++ b/docs/investors/KAIROS_Investor_Deck.pptx
@@ -9492,6 +9492,143 @@
                 <a:ea typeface="Segoe UI"/>
               </a:rPr>
               <a:t>Our own audit caught it before a live account paid for it. That is the product.</a:t>
+            </a:r>
+          </a:p>
+        </p:txBody>
+      </p:sp>
+      <p:sp>
+        <p:nvSpPr>
+          <p:cNvPr id="17" name="Shape 17">
+            <a:extLst>
+              <a:ext uri="{FF2B5EF4-FFF2-40B4-BE49-F238E27FC236}">
+                <a16:creationId xmlns:a16="http://schemas.microsoft.com/office/drawing/2014/main" id="{22EC8335-72F2-460D-B031-1C4EBA5F0A03}"/>
+              </a:ext>
+            </a:extLst>
+          </p:cNvPr>
+          <p:cNvSpPr/>
+          <p:nvPr/>
+        </p:nvSpPr>
+        <p:spPr>
+          <a:xfrm>
+            <a:off x="762000" y="4476750"/>
+            <a:ext cx="4191000" cy="1809750"/>
+          </a:xfrm>
+          <a:prstGeom prst="rect">
+            <a:avLst/>
+          </a:prstGeom>
+          <a:solidFill>
+            <a:srgbClr val="11151D"/>
+          </a:solidFill>
+          <a:ln w="12700">
+            <a:solidFill>
+              <a:srgbClr val="3A3222"/>
+            </a:solidFill>
+          </a:ln>
+        </p:spPr>
+        <p:txBody>
+          <a:bodyPr wrap="square" rtlCol="0"/>
+          <a:lstStyle/>
+          <a:p>
+            <a:r>
+              <a:rPr/>
+              <a:t/>
+            </a:r>
+          </a:p>
+        </p:txBody>
+      </p:sp>
+      <p:sp>
+        <p:nvSpPr>
+          <p:cNvPr id="18" name="TextBox 18">
+            <a:extLst>
+              <a:ext uri="{FF2B5EF4-FFF2-40B4-BE49-F238E27FC236}">
+                <a16:creationId xmlns:a16="http://schemas.microsoft.com/office/drawing/2014/main" id="{F1BF8D94-371C-48A6-9EB9-44681AF8EA05}"/>
+              </a:ext>
+            </a:extLst>
+          </p:cNvPr>
+          <p:cNvSpPr txBox="1"/>
+          <p:nvPr/>
+        </p:nvSpPr>
+        <p:spPr>
+          <a:xfrm>
+            <a:off x="1047750" y="4665250"/>
+            <a:ext cx="3619500" cy="285750"/>
+          </a:xfrm>
+        </p:spPr>
+        <p:txBody>
+          <a:bodyPr wrap="square" rtlCol="0"/>
+          <a:lstStyle/>
+          <a:p>
+            <a:pPr algn="l"/>
+            <a:r>
+              <a:rPr sz="1200" b="1">
+                <a:solidFill>
+                  <a:srgbClr val="F0B429"/>
+                </a:solidFill>
+              </a:rPr>
+              <a:t>AND THEN EIGHT MORE</a:t>
+            </a:r>
+          </a:p>
+        </p:txBody>
+      </p:sp>
+      <p:sp>
+        <p:nvSpPr>
+          <p:cNvPr id="19" name="TextBox 19">
+            <a:extLst>
+              <a:ext uri="{FF2B5EF4-FFF2-40B4-BE49-F238E27FC236}">
+                <a16:creationId xmlns:a16="http://schemas.microsoft.com/office/drawing/2014/main" id="{B2E3A14A-E3E6-47D8-B5BD-23D8C13F16BE}"/>
+              </a:ext>
+            </a:extLst>
+          </p:cNvPr>
+          <p:cNvSpPr txBox="1"/>
+          <p:nvPr/>
+        </p:nvSpPr>
+        <p:spPr>
+          <a:xfrm>
+            <a:off x="1047750" y="4933950"/>
+            <a:ext cx="3619500" cy="1295400"/>
+          </a:xfrm>
+        </p:spPr>
+        <p:txBody>
+          <a:bodyPr wrap="square" rtlCol="0">
+            <a:normAutofit/>
+          </a:bodyPr>
+          <a:lstStyle/>
+          <a:p>
+            <a:pPr algn="l"/>
+            <a:r>
+              <a:rPr sz="1100">
+                <a:solidFill>
+                  <a:srgbClr val="8B94A6"/>
+                </a:solidFill>
+              </a:rPr>
+              <a:t>•Risk limits froze at process start, so a tightened loss cap bound only after a restart.</a:t>
+            </a:r>
+            <a:br/>
+            <a:r>
+              <a:rPr sz="1100">
+                <a:solidFill>
+                  <a:srgbClr val="8B94A6"/>
+                </a:solidFill>
+              </a:rPr>
+              <a:t>•The test suite could arm live mode and write into the production audit trail.</a:t>
+            </a:r>
+            <a:br/>
+            <a:r>
+              <a:rPr sz="1100">
+                <a:solidFill>
+                  <a:srgbClr val="8B94A6"/>
+                </a:solidFill>
+              </a:rPr>
+              <a:t>•A restart reported LIVE while running paper.</a:t>
+            </a:r>
+            <a:br/>
+            <a:r>
+              <a:rPr sz="1100">
+                <a:solidFill>
+                  <a:srgbClr val="8B94A6"/>
+                </a:solidFill>
+              </a:rPr>
+              <a:t>•The live broker account number sat in a committed test fixture.</a:t>
             </a:r>
           </a:p>
         </p:txBody>

</xml_diff>

<commit_message>
Carry the tenth defect into the investor kit
The published integrity list said nine. The ledger-rewrite hazard found
immediately after it is a money-path defect of the same class as the others: the
paper book is the evidence, and an interrupted write used to replace that
evidence with a fresh, healthy-looking account.

Counts re-derived from the tree rather than typed from memory.
</commit_message>
<xml_diff>
--- a/docs/investors/KAIROS_Investor_Deck.pptx
+++ b/docs/investors/KAIROS_Investor_Deck.pptx
@@ -9565,7 +9565,7 @@
                   <a:srgbClr val="F0B429"/>
                 </a:solidFill>
               </a:rPr>
-              <a:t>AND THEN EIGHT MORE</a:t>
+              <a:t>AND THEN NINE MORE</a:t>
             </a:r>
           </a:p>
         </p:txBody>
@@ -9596,7 +9596,7 @@
           <a:p>
             <a:pPr algn="l"/>
             <a:r>
-              <a:rPr sz="1100">
+              <a:rPr sz="1000">
                 <a:solidFill>
                   <a:srgbClr val="8B94A6"/>
                 </a:solidFill>
@@ -9605,16 +9605,25 @@
             </a:r>
             <a:br/>
             <a:r>
-              <a:rPr sz="1100">
+              <a:rPr sz="1000">
                 <a:solidFill>
                   <a:srgbClr val="8B94A6"/>
                 </a:solidFill>
               </a:rPr>
+              <a:t>•Ledgers were written in place — a torn write reset the paper book to full capital.</a:t>
+            </a:r>
+            <a:br/>
+            <a:r>
+              <a:rPr sz="1000">
+                <a:solidFill>
+                  <a:srgbClr val="8B94A6"/>
+                </a:solidFill>
+              </a:rPr>
               <a:t>•The test suite could arm live mode and write into the production audit trail.</a:t>
             </a:r>
             <a:br/>
             <a:r>
-              <a:rPr sz="1100">
+              <a:rPr sz="1000">
                 <a:solidFill>
                   <a:srgbClr val="8B94A6"/>
                 </a:solidFill>
@@ -9623,12 +9632,12 @@
             </a:r>
             <a:br/>
             <a:r>
-              <a:rPr sz="1100">
+              <a:rPr sz="1000">
                 <a:solidFill>
                   <a:srgbClr val="8B94A6"/>
                 </a:solidFill>
               </a:rPr>
-              <a:t>•The live broker account number sat in a committed test fixture.</a:t>
+              <a:t>•The live broker account number sat in a committed fixture.</a:t>
             </a:r>
           </a:p>
         </p:txBody>

</xml_diff>

<commit_message>
The regenerated ledger was reading a four-day-old sweep log
Ties in the sweep-log choice were broken on row count alone over a sorted glob, so the
2026-10-21 re-run lost to the 2026-10-17 run of the same width and the pack published
evidence produced before its own strategy fix. The current table is 5 of 14 profitable,
not 8, and three names the deck showed as winners are losses.

Also: a sweep ratio was only read when the word "profitable" was glued to it, a book mean
only when "mean" sat beside it, and every rule checked a digit while the pack's worst false
claim was a noun — "Walk-forward sweep, 100 strategies per instrument" survived a full
refresh because the 100 beside it was verified. The library credit is denied now.
</commit_message>
<xml_diff>
--- a/docs/investors/KAIROS_Investor_Deck.pptx
+++ b/docs/investors/KAIROS_Investor_Deck.pptx
@@ -320,7 +320,7 @@
                 <a:latin typeface="Segoe UI"/>
                 <a:ea typeface="Segoe UI"/>
               </a:rPr>
-              <a:t>KAIROS v2.6.1 · 2026-10-21 · github.com/zhaider5142009-oss/kairos</a:t>
+              <a:t>KAIROS v2.6.2 · 2026-10-21 · github.com/zhaider5142009-oss/kairos</a:t>
             </a:r>
           </a:p>
         </p:txBody>
@@ -931,9 +931,15 @@
                 <a:latin typeface="Segoe UI"/>
                 <a:ea typeface="Segoe UI"/>
               </a:rPr>
-              <a:t>Walk-forward sweep, 100 strategies per instrument,</a:t>
-            </a:r>
-            <a:br/>
+              <a:t>Walk-forward sweep, one blended signal per instrument,</a:t>
+            </a:r>
+          </a:p>
+          <a:p>
+            <a:pPr algn="l">
+              <a:lnSpc>
+                <a:spcPct val="120000"/>
+              </a:lnSpc>
+            </a:pPr>
             <a:r>
               <a:rPr sz="1100">
                 <a:solidFill>
@@ -4672,7 +4678,7 @@
                 <a:latin typeface="Consolas"/>
                 <a:ea typeface="Consolas"/>
               </a:rPr>
-              <a:t>python -m pytest tests -q        # 283 tests</a:t>
+              <a:t>python -m pytest tests -q        # 286 tests</a:t>
             </a:r>
           </a:p>
           <a:p>
@@ -6015,7 +6021,7 @@
                 <a:latin typeface="Consolas"/>
                 <a:ea typeface="Consolas"/>
               </a:rPr>
-              <a:t>283</a:t>
+              <a:t>286</a:t>
             </a:r>
           </a:p>
           <a:p>
@@ -8538,7 +8544,7 @@
                 <a:latin typeface="Segoe UI"/>
                 <a:ea typeface="Segoe UI"/>
               </a:rPr>
-              <a:t>A public repository: 12,354 lines, 37 modules, 283 tests, MIT.</a:t>
+              <a:t>A public repository: 12,354 lines, 37 modules, 286 tests, MIT.</a:t>
             </a:r>
           </a:p>
           <a:p>

</xml_diff>

<commit_message>
A call whose symbol the registry could not name was deleted from the record
resolve_outcomes() marked an unresolvable snapshot resolved with
outcome=no-instrument and no realized return, so it left both the numerator and
the denominator of the forward record — permanently, silently, and with
`directional` stamped from whatever entry threshold was configured that day.
Most pending calls sat on four watchlist symbols whose registry entries are
rebuilt at runtime, so one cycle with a missing registry, or a journal copied to
a fresh deploy, would have erased the first measurable hit rate before it could
be measured. The row is left pending and retried now, the label on the row is the
only thing that decides whether it claimed a direction, and the ledger prints the
queue beside the answered part so a stalled record is visible rather than empty.
</commit_message>
<xml_diff>
--- a/docs/investors/KAIROS_Investor_Deck.pptx
+++ b/docs/investors/KAIROS_Investor_Deck.pptx
@@ -4678,7 +4678,7 @@
                 <a:latin typeface="Consolas"/>
                 <a:ea typeface="Consolas"/>
               </a:rPr>
-              <a:t>python -m pytest tests -q        # 286 tests</a:t>
+              <a:t>python -m pytest tests -q        # 287 tests</a:t>
             </a:r>
           </a:p>
           <a:p>
@@ -5757,7 +5757,7 @@
                 <a:latin typeface="Consolas"/>
                 <a:ea typeface="Consolas"/>
               </a:rPr>
-              <a:t>12,354</a:t>
+              <a:t>12,358</a:t>
             </a:r>
           </a:p>
           <a:p>
@@ -6021,7 +6021,7 @@
                 <a:latin typeface="Consolas"/>
                 <a:ea typeface="Consolas"/>
               </a:rPr>
-              <a:t>286</a:t>
+              <a:t>287</a:t>
             </a:r>
           </a:p>
           <a:p>
@@ -8544,7 +8544,7 @@
                 <a:latin typeface="Segoe UI"/>
                 <a:ea typeface="Segoe UI"/>
               </a:rPr>
-              <a:t>A public repository: 12,354 lines, 37 modules, 286 tests, MIT.</a:t>
+              <a:t>A public repository: 12,358 lines, 37 modules, 287 tests, MIT.</a:t>
             </a:r>
           </a:p>
           <a:p>

</xml_diff>

<commit_message>
A degraded venue read that answered zero disabled the daily-loss breaker
Every guard on the live path compares against equity, so each was written as
`if equity > 0`. A portal that answers with nothing — zero cash, no holdings,
no error raised — produces exactly the equity that makes those guards skip, and
it also stamped the day's P&L baseline at zero, which is never recovered: the
session reports flat afterwards and both loss brakes are comparisons against
that one number. The pre-trade gate had the same blind spot inverted, accepting
a negative equity as positive knowledge.

Six tests, one of them the whole shape end to end: outage at the open, healthy
book, real loss, breaker fires.
</commit_message>
<xml_diff>
--- a/docs/investors/KAIROS_Investor_Deck.pptx
+++ b/docs/investors/KAIROS_Investor_Deck.pptx
@@ -4678,7 +4678,7 @@
                 <a:latin typeface="Consolas"/>
                 <a:ea typeface="Consolas"/>
               </a:rPr>
-              <a:t>python -m pytest tests -q        # 289 tests</a:t>
+              <a:t>python -m pytest tests -q        # 295 tests</a:t>
             </a:r>
           </a:p>
           <a:p>
@@ -5757,7 +5757,7 @@
                 <a:latin typeface="Consolas"/>
                 <a:ea typeface="Consolas"/>
               </a:rPr>
-              <a:t>12,424</a:t>
+              <a:t>12,459</a:t>
             </a:r>
           </a:p>
           <a:p>
@@ -6021,7 +6021,7 @@
                 <a:latin typeface="Consolas"/>
                 <a:ea typeface="Consolas"/>
               </a:rPr>
-              <a:t>289</a:t>
+              <a:t>295</a:t>
             </a:r>
           </a:p>
           <a:p>
@@ -8544,7 +8544,7 @@
                 <a:latin typeface="Segoe UI"/>
                 <a:ea typeface="Segoe UI"/>
               </a:rPr>
-              <a:t>A public repository: 12,424 lines, 37 modules, 289 tests, MIT.</a:t>
+              <a:t>A public repository: 12,459 lines, 37 modules, 295 tests, MIT.</a:t>
             </a:r>
           </a:p>
           <a:p>

</xml_diff>

<commit_message>
An order whose numbers were not numbers cleared every guard
price <= 0, qty * price > cap, lo <= price <= hi and the penny screen's
px < min_px are all false of a NaN, so one unusable figure satisfied the
notional cap, the broker band and the liquidity screen at once. Finiteness
is now tested before bounds on the shared gate and at the bridge; the price
the desk quotes is refused where it is read; the Yahoo loader stops turning
a literal NaN into a bar; a band the bridge could not read is journalled as
unchecked; and a screen that cannot see answers reject instead of pass.
</commit_message>
<xml_diff>
--- a/docs/investors/KAIROS_Investor_Deck.pptx
+++ b/docs/investors/KAIROS_Investor_Deck.pptx
@@ -320,7 +320,7 @@
                 <a:latin typeface="Segoe UI"/>
                 <a:ea typeface="Segoe UI"/>
               </a:rPr>
-              <a:t>KAIROS v2.6.2 · 2026-10-21 · github.com/zhaider5142009-oss/kairos</a:t>
+              <a:t>KAIROS v2.6.2 · 2026-10-22 · github.com/zhaider5142009-oss/kairos</a:t>
             </a:r>
           </a:p>
         </p:txBody>
@@ -4678,7 +4678,7 @@
                 <a:latin typeface="Consolas"/>
                 <a:ea typeface="Consolas"/>
               </a:rPr>
-              <a:t>python -m pytest tests -q        # 295 tests</a:t>
+              <a:t>python -m pytest tests -q        # 307 tests</a:t>
             </a:r>
           </a:p>
           <a:p>
@@ -5757,7 +5757,7 @@
                 <a:latin typeface="Consolas"/>
                 <a:ea typeface="Consolas"/>
               </a:rPr>
-              <a:t>12,459</a:t>
+              <a:t>12,533</a:t>
             </a:r>
           </a:p>
           <a:p>
@@ -6021,7 +6021,7 @@
                 <a:latin typeface="Consolas"/>
                 <a:ea typeface="Consolas"/>
               </a:rPr>
-              <a:t>295</a:t>
+              <a:t>307</a:t>
             </a:r>
           </a:p>
           <a:p>
@@ -6246,7 +6246,7 @@
                 <a:latin typeface="Consolas"/>
                 <a:ea typeface="Consolas"/>
               </a:rPr>
-              <a:t>figures verified against the repository on 2026-10-21</a:t>
+              <a:t>figures verified against the repository on 2026-10-22</a:t>
             </a:r>
           </a:p>
         </p:txBody>
@@ -8544,7 +8544,7 @@
                 <a:latin typeface="Segoe UI"/>
                 <a:ea typeface="Segoe UI"/>
               </a:rPr>
-              <a:t>A public repository: 12,459 lines, 37 modules, 295 tests, MIT.</a:t>
+              <a:t>A public repository: 12,533 lines, 37 modules, 307 tests, MIT.</a:t>
             </a:r>
           </a:p>
           <a:p>

</xml_diff>

<commit_message>
A price of exactly zero divided the position sizer
Zero is finite, so it survived the finiteness guard, and every figure in the
sizing block is a quotient by the price. A vendor serving a halted name as 0.0
raised out of the instrument loop, past the try that only wraps the prediction
call, and ended the cycle in which every other position's stop and target were
meant to be managed. A quote at or below zero is now refused where it is read,
before anything is fitted or sized.
</commit_message>
<xml_diff>
--- a/docs/investors/KAIROS_Investor_Deck.pptx
+++ b/docs/investors/KAIROS_Investor_Deck.pptx
@@ -4678,7 +4678,7 @@
                 <a:latin typeface="Consolas"/>
                 <a:ea typeface="Consolas"/>
               </a:rPr>
-              <a:t>python -m pytest tests -q        # 307 tests</a:t>
+              <a:t>python -m pytest tests -q        # 309 tests</a:t>
             </a:r>
           </a:p>
           <a:p>
@@ -5757,7 +5757,7 @@
                 <a:latin typeface="Consolas"/>
                 <a:ea typeface="Consolas"/>
               </a:rPr>
-              <a:t>12,533</a:t>
+              <a:t>12,538</a:t>
             </a:r>
           </a:p>
           <a:p>
@@ -6021,7 +6021,7 @@
                 <a:latin typeface="Consolas"/>
                 <a:ea typeface="Consolas"/>
               </a:rPr>
-              <a:t>307</a:t>
+              <a:t>309</a:t>
             </a:r>
           </a:p>
           <a:p>
@@ -8544,7 +8544,7 @@
                 <a:latin typeface="Segoe UI"/>
                 <a:ea typeface="Segoe UI"/>
               </a:rPr>
-              <a:t>A public repository: 12,533 lines, 37 modules, 307 tests, MIT.</a:t>
+              <a:t>A public repository: 12,538 lines, 37 modules, 309 tests, MIT.</a:t>
             </a:r>
           </a:p>
           <a:p>

</xml_diff>

<commit_message>
A broker that did not answer was reported as an account holding nothing
MetaTrader spells a failed retrieve as None and a flat account as an empty
sequence; the bridge translated the first into the second, so gross exposure
summed to nothing, the position cap cleared, and reconciliation dropped the
live trades whose stop it was supposed to own. Both JS Global holdings views
did the same thing with `except Exception: data = None`.

None now travels as its own answer to the gate, the desk and the journal: an
unreadable position list blocks entries and prints as unreadable instead of
zero percent, a view that could not be read raises as a venue loss, and
forgetting a managed entry requires a read to base it on.
</commit_message>
<xml_diff>
--- a/docs/investors/KAIROS_Investor_Deck.pptx
+++ b/docs/investors/KAIROS_Investor_Deck.pptx
@@ -4678,7 +4678,7 @@
                 <a:latin typeface="Consolas"/>
                 <a:ea typeface="Consolas"/>
               </a:rPr>
-              <a:t>python -m pytest tests -q        # 309 tests</a:t>
+              <a:t>python -m pytest tests -q        # 319 tests</a:t>
             </a:r>
           </a:p>
           <a:p>
@@ -5757,7 +5757,7 @@
                 <a:latin typeface="Consolas"/>
                 <a:ea typeface="Consolas"/>
               </a:rPr>
-              <a:t>12,538</a:t>
+              <a:t>12,596</a:t>
             </a:r>
           </a:p>
           <a:p>
@@ -6021,7 +6021,7 @@
                 <a:latin typeface="Consolas"/>
                 <a:ea typeface="Consolas"/>
               </a:rPr>
-              <a:t>309</a:t>
+              <a:t>319</a:t>
             </a:r>
           </a:p>
           <a:p>
@@ -8544,7 +8544,7 @@
                 <a:latin typeface="Segoe UI"/>
                 <a:ea typeface="Segoe UI"/>
               </a:rPr>
-              <a:t>A public repository: 12,538 lines, 37 modules, 309 tests, MIT.</a:t>
+              <a:t>A public repository: 12,596 lines, 37 modules, 319 tests, MIT.</a:t>
             </a:r>
           </a:p>
           <a:p>

</xml_diff>

<commit_message>
The pack now says what the attribution spine does, and the deck has room to say it
Regenerated the track record, re-stamped every quoted figure against the
working tree (13,112 lines, 37 modules, 395 tests) and added the spine to the
whitepaper's layer table, its calibration section, its reproduction list and
the one-pager, landing page and deck notes. The integrity count went to
fifty-three: the regime flag whose type let it read back as its own opposite
once it had been through a disk, and a desk whose script had not parsed since
the order panel shipped.

In the deck, "Architecture that transfers" was still subtitled five
properties above six cards, so the anti-rot card folded its catalog check into
council integrity — the same guarantee, one line, no fact lost — and the freed
card carries attribution. The venue card now names PMEX futures rather than a
generic PMX scaffold.
</commit_message>
<xml_diff>
--- a/docs/investors/KAIROS_Investor_Deck.pptx
+++ b/docs/investors/KAIROS_Investor_Deck.pptx
@@ -1092,7 +1092,7 @@
                 <a:latin typeface="Segoe UI"/>
                 <a:ea typeface="Segoe UI"/>
               </a:rPr>
-              <a:t>five properties worth more than any single signal</a:t>
+              <a:t>six properties worth more than any single signal</a:t>
             </a:r>
           </a:p>
         </p:txBody>
@@ -1552,7 +1552,10 @@
                 <a:latin typeface="Segoe UI"/>
                 <a:ea typeface="Segoe UI"/>
               </a:rPr>
-              <a:t>A named seat is answered by that seat only. A dead model shrinks the council instead of substituting a second opinion into the median.</a:t>
+              <a:t>A named seat is answered by that seat
+only: a dead model shrinks the council
+instead of doubling an opinion in the
+median, and retired slugs get reported.</a:t>
             </a:r>
           </a:p>
         </p:txBody>
@@ -1622,7 +1625,7 @@
                 <a:latin typeface="Segoe UI"/>
                 <a:ea typeface="Segoe UI"/>
               </a:rPr>
-              <a:t>Anti-rot by design</a:t>
+              <a:t>Attribution, per regime</a:t>
             </a:r>
           </a:p>
         </p:txBody>
@@ -1662,7 +1665,10 @@
                 <a:latin typeface="Segoe UI"/>
                 <a:ea typeface="Segoe UI"/>
               </a:rPr>
-              <a:t>Vendor model slugs retire without warning. Configured seats are checked against the live catalog every six hours and dead ones are reported, never hidden.</a:t>
+              <a:t>Each vote is weighted by realized
+out-of-sample skill, per horizon and
+per regime. Thin evidence earns no
+weight: the poll stays flat.</a:t>
             </a:r>
           </a:p>
         </p:txBody>
@@ -1882,7 +1888,10 @@
                 <a:latin typeface="Segoe UI"/>
                 <a:ea typeface="Segoe UI"/>
               </a:rPr>
-              <a:t>The risk layer does not know which broker is underneath it. PSX today, MT5 now, PMX scaffolded: swap the venue, keep the discipline.</a:t>
+              <a:t>The risk layer does not know which
+broker is underneath it. PSX cash,
+MT5 commodities and FX, PMEX futures:
+swap the venue, keep the discipline.</a:t>
             </a:r>
           </a:p>
         </p:txBody>
@@ -4678,7 +4687,7 @@
                 <a:latin typeface="Consolas"/>
                 <a:ea typeface="Consolas"/>
               </a:rPr>
-              <a:t>python -m pytest tests -q        # 373 tests</a:t>
+              <a:t>python -m pytest tests -q        # 395 tests</a:t>
             </a:r>
           </a:p>
           <a:p>
@@ -5757,7 +5766,7 @@
                 <a:latin typeface="Consolas"/>
                 <a:ea typeface="Consolas"/>
               </a:rPr>
-              <a:t>12,990</a:t>
+              <a:t>13,112</a:t>
             </a:r>
           </a:p>
           <a:p>
@@ -6021,7 +6030,7 @@
                 <a:latin typeface="Consolas"/>
                 <a:ea typeface="Consolas"/>
               </a:rPr>
-              <a:t>373</a:t>
+              <a:t>395</a:t>
             </a:r>
           </a:p>
           <a:p>
@@ -8544,7 +8553,7 @@
                 <a:latin typeface="Segoe UI"/>
                 <a:ea typeface="Segoe UI"/>
               </a:rPr>
-              <a:t>A public repository: 12,990 lines, 37 modules, 373 tests, MIT.</a:t>
+              <a:t>A public repository: 13,112 lines, 37 modules, 395 tests, MIT.</a:t>
             </a:r>
           </a:p>
           <a:p>

</xml_diff>

<commit_message>
The pack and the deck now say what the repository says
Re-stamped after the Binance venue, the serializer and the GPU bridge landed:
17,212 lines across 42 modules, 667 collected tests, 3,536 predictions journaled,
391 autopilot cycles, 263 horizons matured and all 263 of them non-trades, 2 fills
and −Rs 13.05 realized on the paper book. The sweep still lands 5 profitable of 14.

The .pptx is the copy that gets emailed, and `--write` cannot reach inside a zip,
so it was patched by hand: three slides carried the test total, two carried the
module count, and slide 5's repository triple was reworded into the shapes the
figure rules can actually read. No directional hit rate is quoted anywhere, as
before — none exists yet, and the pack says so on the page that shows the record.
</commit_message>
<xml_diff>
--- a/docs/investors/KAIROS_Investor_Deck.pptx
+++ b/docs/investors/KAIROS_Investor_Deck.pptx
@@ -4684,7 +4684,7 @@
                 <a:latin typeface="Consolas"/>
                 <a:ea typeface="Consolas"/>
               </a:rPr>
-              <a:t>python -m pytest tests -q        # 621 tests</a:t>
+              <a:t>python -m pytest tests -q        # 667 tests</a:t>
             </a:r>
           </a:p>
           <a:p>
@@ -5763,7 +5763,7 @@
                 <a:latin typeface="Consolas"/>
                 <a:ea typeface="Consolas"/>
               </a:rPr>
-              <a:t>16,347</a:t>
+              <a:t>17,212</a:t>
             </a:r>
           </a:p>
           <a:p>
@@ -5800,7 +5800,7 @@
                 <a:latin typeface="Segoe UI"/>
                 <a:ea typeface="Segoe UI"/>
               </a:rPr>
-              <a:t>41 modules, public under MIT, no closed core</a:t>
+              <a:t>42 modules, public under MIT, no closed core</a:t>
             </a:r>
           </a:p>
         </p:txBody>
@@ -6027,7 +6027,7 @@
                 <a:latin typeface="Consolas"/>
                 <a:ea typeface="Consolas"/>
               </a:rPr>
-              <a:t>621</a:t>
+              <a:t>667</a:t>
             </a:r>
           </a:p>
           <a:p>
@@ -8550,7 +8550,7 @@
                 <a:latin typeface="Segoe UI"/>
                 <a:ea typeface="Segoe UI"/>
               </a:rPr>
-              <a:t>A public repository: 16,347 lines, 41 modules, 621 tests, MIT.</a:t>
+              <a:t>A public repository: 17,212 lines of Python, 42 modules, 667 passing tests, MIT.</a:t>
             </a:r>
           </a:p>
           <a:p>

</xml_diff>

<commit_message>
The pack and the deck carry the merge fix: 17,226 lines, 673 tests
Re-stamped after the history-merge fix landed. Modules still 42, the sweep still
5 profitable of 14, the ledger still 263 matured horizons with every one of them
a non-trade, the paper book still 2 fills and −Rs 13.05. The date rolled to
2026-10-24 while the work ran, so both the cover stamp and the slide footer that
claims the figures were verified that day moved with it — a footer that promises
a same-day check has to be true on the day it is read.

The .pptx carries the same three figures as the markdown now, and slide 5's
repository triple is in the form the figure rules can reach, so the deck's line
count and test total are compared rather than merely printed.
</commit_message>
<xml_diff>
--- a/docs/investors/KAIROS_Investor_Deck.pptx
+++ b/docs/investors/KAIROS_Investor_Deck.pptx
@@ -320,7 +320,7 @@
                 <a:latin typeface="Segoe UI"/>
                 <a:ea typeface="Segoe UI"/>
               </a:rPr>
-              <a:t>KAIROS v2.6.2 · 2026-10-23 · github.com/zhaider5142009-oss/kairos</a:t>
+              <a:t>KAIROS v2.6.2 · 2026-10-24 · github.com/zhaider5142009-oss/kairos</a:t>
             </a:r>
           </a:p>
         </p:txBody>
@@ -4684,7 +4684,7 @@
                 <a:latin typeface="Consolas"/>
                 <a:ea typeface="Consolas"/>
               </a:rPr>
-              <a:t>python -m pytest tests -q        # 667 tests</a:t>
+              <a:t>python -m pytest tests -q        # 673 tests</a:t>
             </a:r>
           </a:p>
           <a:p>
@@ -5763,7 +5763,7 @@
                 <a:latin typeface="Consolas"/>
                 <a:ea typeface="Consolas"/>
               </a:rPr>
-              <a:t>17,212</a:t>
+              <a:t>17,226</a:t>
             </a:r>
           </a:p>
           <a:p>
@@ -6027,7 +6027,7 @@
                 <a:latin typeface="Consolas"/>
                 <a:ea typeface="Consolas"/>
               </a:rPr>
-              <a:t>667</a:t>
+              <a:t>673</a:t>
             </a:r>
           </a:p>
           <a:p>
@@ -6252,7 +6252,7 @@
                 <a:latin typeface="Consolas"/>
                 <a:ea typeface="Consolas"/>
               </a:rPr>
-              <a:t>figures verified against the repository on 2026-10-23</a:t>
+              <a:t>figures verified against the repository on 2026-10-24</a:t>
             </a:r>
           </a:p>
         </p:txBody>
@@ -8550,7 +8550,7 @@
                 <a:latin typeface="Segoe UI"/>
                 <a:ea typeface="Segoe UI"/>
               </a:rPr>
-              <a:t>A public repository: 17,212 lines of Python, 42 modules, 667 passing tests, MIT.</a:t>
+              <a:t>A public repository: 17,226 lines of Python, 42 modules, 673 passing tests, MIT.</a:t>
             </a:r>
           </a:p>
           <a:p>

</xml_diff>

<commit_message>
A promise about the journal that was checked against the wrong object
The previous commit put the size brake on the desk row and wrote that the
forward record carried it too. `feedback.Snapshot` had no veto column at
all, so the sentence was false and the test that seemed to prove it was
reading the cycle response, not the journal line. Now `record()` copies
the strength and the member that raised it into two optional snapshot
fields, and the multiplier is recomputed rather than journalled — one
rule, one stored number, so a later change to the cut cannot leave a
record that contradicts itself. A resolve pass rewrites the whole file,
so a test holds the brake through that rewrite; the ~3,700 legacy rows
written before the columns existed still mature.

This is also the first test that runs the loop which trades:
`Autopilot.cycle()` had never been executed by the suite.
</commit_message>
<xml_diff>
--- a/docs/investors/KAIROS_Investor_Deck.pptx
+++ b/docs/investors/KAIROS_Investor_Deck.pptx
@@ -4710,7 +4710,7 @@
                 <a:latin typeface="Consolas"/>
                 <a:ea typeface="Consolas"/>
               </a:rPr>
-              <a:t>python -m pytest tests -q        # 701 tests</a:t>
+              <a:t>python -m pytest tests -q        # 705 tests</a:t>
             </a:r>
           </a:p>
           <a:p>
@@ -5789,7 +5789,7 @@
                 <a:latin typeface="Consolas"/>
                 <a:ea typeface="Consolas"/>
               </a:rPr>
-              <a:t>17,425</a:t>
+              <a:t>17,441</a:t>
             </a:r>
           </a:p>
           <a:p>
@@ -6053,7 +6053,7 @@
                 <a:latin typeface="Consolas"/>
                 <a:ea typeface="Consolas"/>
               </a:rPr>
-              <a:t>701</a:t>
+              <a:t>705</a:t>
             </a:r>
           </a:p>
           <a:p>
@@ -8610,7 +8610,7 @@
                 <a:latin typeface="Segoe UI"/>
                 <a:ea typeface="Segoe UI"/>
               </a:rPr>
-              <a:t>A public repository: 17,425 lines of Python, 42 modules, 701 passing tests, MIT.</a:t>
+              <a:t>A public repository: 17,441 lines of Python, 42 modules, 705 passing tests, MIT.</a:t>
             </a:r>
           </a:p>
           <a:p>

</xml_diff>

<commit_message>
A volume-balance feature was scaled by a running sum that passes through zero
</commit_message>
<xml_diff>
--- a/docs/investors/KAIROS_Investor_Deck.pptx
+++ b/docs/investors/KAIROS_Investor_Deck.pptx
@@ -4422,7 +4422,7 @@
                 <a:latin typeface="Segoe UI"/>
                 <a:ea typeface="Segoe UI"/>
               </a:rPr>
-              <a:t>The journal grows on its own every ten minutes: every prediction is in the dated ledger; 404 horizons matured, zero directional calls resolved so far. Nobody has to trust a slide to check this number; it prints itself, and it will print the losses too.</a:t>
+              <a:t>The journal grows on its own every ten minutes: every prediction is in the dated ledger; 429 horizons matured, zero directional calls resolved so far. Nobody has to trust a slide to check this number; it prints itself, and it will print the losses too.</a:t>
             </a:r>
           </a:p>
         </p:txBody>
@@ -4710,7 +4710,7 @@
                 <a:latin typeface="Consolas"/>
                 <a:ea typeface="Consolas"/>
               </a:rPr>
-              <a:t>python -m pytest tests -q        # 875 tests</a:t>
+              <a:t>python -m pytest tests -q        # 885 tests</a:t>
             </a:r>
           </a:p>
           <a:p>
@@ -5789,7 +5789,7 @@
                 <a:latin typeface="Consolas"/>
                 <a:ea typeface="Consolas"/>
               </a:rPr>
-              <a:t>18,068</a:t>
+              <a:t>18,080</a:t>
             </a:r>
           </a:p>
           <a:p>
@@ -6053,7 +6053,7 @@
                 <a:latin typeface="Consolas"/>
                 <a:ea typeface="Consolas"/>
               </a:rPr>
-              <a:t>875</a:t>
+              <a:t>885</a:t>
             </a:r>
           </a:p>
           <a:p>
@@ -8610,7 +8610,7 @@
                 <a:latin typeface="Segoe UI"/>
                 <a:ea typeface="Segoe UI"/>
               </a:rPr>
-              <a:t>A public repository: 18,068 lines of Python, 43 modules, 875 passing tests, MIT.</a:t>
+              <a:t>A public repository: 18,080 lines of Python, 43 modules, 885 passing tests, MIT.</a:t>
             </a:r>
           </a:p>
           <a:p>
@@ -8742,7 +8742,7 @@
                 <a:latin typeface="Segoe UI"/>
                 <a:ea typeface="Segoe UI"/>
               </a:rPr>
-              <a:t>404 horizons matured, and all 404 were non-trades.</a:t>
+              <a:t>429 horizons matured, and all 429 were non-trades.</a:t>
             </a:r>
           </a:p>
           <a:p>

</xml_diff>

<commit_message>
A neural model was paid for running backwards on its own validation
</commit_message>
<xml_diff>
--- a/docs/investors/KAIROS_Investor_Deck.pptx
+++ b/docs/investors/KAIROS_Investor_Deck.pptx
@@ -4710,7 +4710,7 @@
                 <a:latin typeface="Consolas"/>
                 <a:ea typeface="Consolas"/>
               </a:rPr>
-              <a:t>python -m pytest tests -q        # 885 tests</a:t>
+              <a:t>python -m pytest tests -q        # 900 tests</a:t>
             </a:r>
           </a:p>
           <a:p>
@@ -5789,7 +5789,7 @@
                 <a:latin typeface="Consolas"/>
                 <a:ea typeface="Consolas"/>
               </a:rPr>
-              <a:t>18,080</a:t>
+              <a:t>18,111</a:t>
             </a:r>
           </a:p>
           <a:p>
@@ -6053,7 +6053,7 @@
                 <a:latin typeface="Consolas"/>
                 <a:ea typeface="Consolas"/>
               </a:rPr>
-              <a:t>885</a:t>
+              <a:t>900</a:t>
             </a:r>
           </a:p>
           <a:p>
@@ -8610,7 +8610,7 @@
                 <a:latin typeface="Segoe UI"/>
                 <a:ea typeface="Segoe UI"/>
               </a:rPr>
-              <a:t>A public repository: 18,080 lines of Python, 43 modules, 885 passing tests, MIT.</a:t>
+              <a:t>A public repository: 18,111 lines of Python, 43 modules, 900 passing tests, MIT.</a:t>
             </a:r>
           </a:p>
           <a:p>

</xml_diff>

<commit_message>
A TradingView alert had nowhere to land, so it lands in a journal
The scanner could be read but nothing could be pushed in. The new
/api/tv/alert route is default-off, fails closed on a blank secret, keeps
its own scoped secret so TradingView never holds the master token, caps
the body at 4 KB, refuses any symbol outside the universe, and appends
to an audit journal through the same writer the rest of the desk uses.
There is no path from it to an order.
</commit_message>
<xml_diff>
--- a/docs/investors/KAIROS_Investor_Deck.pptx
+++ b/docs/investors/KAIROS_Investor_Deck.pptx
@@ -4710,7 +4710,7 @@
                 <a:latin typeface="Consolas"/>
                 <a:ea typeface="Consolas"/>
               </a:rPr>
-              <a:t>python -m pytest tests -q        # 900 tests</a:t>
+              <a:t>python -m pytest tests -q        # 924 tests</a:t>
             </a:r>
           </a:p>
           <a:p>
@@ -5789,7 +5789,7 @@
                 <a:latin typeface="Consolas"/>
                 <a:ea typeface="Consolas"/>
               </a:rPr>
-              <a:t>18,111</a:t>
+              <a:t>18,305</a:t>
             </a:r>
           </a:p>
           <a:p>
@@ -5826,7 +5826,7 @@
                 <a:latin typeface="Segoe UI"/>
                 <a:ea typeface="Segoe UI"/>
               </a:rPr>
-              <a:t>43 modules, public under MIT, no closed core</a:t>
+              <a:t>44 modules, public under MIT, no closed core</a:t>
             </a:r>
           </a:p>
         </p:txBody>
@@ -6053,7 +6053,7 @@
                 <a:latin typeface="Consolas"/>
                 <a:ea typeface="Consolas"/>
               </a:rPr>
-              <a:t>900</a:t>
+              <a:t>924</a:t>
             </a:r>
           </a:p>
           <a:p>
@@ -8610,7 +8610,7 @@
                 <a:latin typeface="Segoe UI"/>
                 <a:ea typeface="Segoe UI"/>
               </a:rPr>
-              <a:t>A public repository: 18,111 lines of Python, 43 modules, 900 passing tests, MIT.</a:t>
+              <a:t>A public repository: 18,305 lines of Python, 44 modules, 924 passing tests, MIT.</a:t>
             </a:r>
           </a:p>
           <a:p>

</xml_diff>

<commit_message>
A LEAN cross-check had no data to check with, so the export exists
The engine is a Docker-hosted .NET backtest and it is not here. Rather than
describe an integration that cannot run, `kairos lean` names each missing
piece — and refuses to call itself ready, because a Docker binary on PATH
with the engine stopped is not a capability. What ships is the half that can
be true now: bars exported to data/lean with a manifest carrying row count,
date span, source and a SHA-256 of the file as written, so a future run can
prove which dataset it read. The manifest says in words that bars are not a
backtest.
</commit_message>
<xml_diff>
--- a/docs/investors/KAIROS_Investor_Deck.pptx
+++ b/docs/investors/KAIROS_Investor_Deck.pptx
@@ -4710,7 +4710,7 @@
                 <a:latin typeface="Consolas"/>
                 <a:ea typeface="Consolas"/>
               </a:rPr>
-              <a:t>python -m pytest tests -q        # 924 tests</a:t>
+              <a:t>python -m pytest tests -q        # 940 tests</a:t>
             </a:r>
           </a:p>
           <a:p>
@@ -5789,7 +5789,7 @@
                 <a:latin typeface="Consolas"/>
                 <a:ea typeface="Consolas"/>
               </a:rPr>
-              <a:t>18,305</a:t>
+              <a:t>18,524</a:t>
             </a:r>
           </a:p>
           <a:p>
@@ -5826,7 +5826,7 @@
                 <a:latin typeface="Segoe UI"/>
                 <a:ea typeface="Segoe UI"/>
               </a:rPr>
-              <a:t>44 modules, public under MIT, no closed core</a:t>
+              <a:t>45 modules, public under MIT, no closed core</a:t>
             </a:r>
           </a:p>
         </p:txBody>
@@ -6053,7 +6053,7 @@
                 <a:latin typeface="Consolas"/>
                 <a:ea typeface="Consolas"/>
               </a:rPr>
-              <a:t>924</a:t>
+              <a:t>940</a:t>
             </a:r>
           </a:p>
           <a:p>
@@ -8610,7 +8610,7 @@
                 <a:latin typeface="Segoe UI"/>
                 <a:ea typeface="Segoe UI"/>
               </a:rPr>
-              <a:t>A public repository: 18,305 lines of Python, 44 modules, 924 passing tests, MIT.</a:t>
+              <a:t>A public repository: 18,524 lines of Python, 45 modules, 940 passing tests, MIT.</a:t>
             </a:r>
           </a:p>
           <a:p>

</xml_diff>

<commit_message>
A KAIROS key was never the ticker the exchange answers to
The registry built every venue symbol out of the instrument key, so ENGRO
(renamed ENGROH), Bank of Punjab (BOP) and Nestle (NESTLE) were fetched under
symbols that do not exist. The board sweep then filed their bars under the
board spelling while history() read the key, leaving Bank of Punjab's series
two days stale and Engro's nine days of bars unreachable. Tickers are now
declared next to the key; the sweep resolves a board name to the registry key
so both streams share one file; the live ticket carries the broker's spelling;
and resolve() accepts the full PSX: form its docstring promised. A migration
tool folds the already-split bar files into the keyed ones.
</commit_message>
<xml_diff>
--- a/docs/investors/KAIROS_Investor_Deck.pptx
+++ b/docs/investors/KAIROS_Investor_Deck.pptx
@@ -4710,7 +4710,7 @@
                 <a:latin typeface="Consolas"/>
                 <a:ea typeface="Consolas"/>
               </a:rPr>
-              <a:t>python -m pytest tests -q        # 940 tests</a:t>
+              <a:t>python -m pytest tests -q        # 947 tests</a:t>
             </a:r>
           </a:p>
           <a:p>
@@ -5789,7 +5789,7 @@
                 <a:latin typeface="Consolas"/>
                 <a:ea typeface="Consolas"/>
               </a:rPr>
-              <a:t>18,524</a:t>
+              <a:t>18,549</a:t>
             </a:r>
           </a:p>
           <a:p>
@@ -6053,7 +6053,7 @@
                 <a:latin typeface="Consolas"/>
                 <a:ea typeface="Consolas"/>
               </a:rPr>
-              <a:t>940</a:t>
+              <a:t>947</a:t>
             </a:r>
           </a:p>
           <a:p>
@@ -8610,7 +8610,7 @@
                 <a:latin typeface="Segoe UI"/>
                 <a:ea typeface="Segoe UI"/>
               </a:rPr>
-              <a:t>A public repository: 18,524 lines of Python, 45 modules, 940 passing tests, MIT.</a:t>
+              <a:t>A public repository: 18,549 lines of Python, 45 modules, 947 passing tests, MIT.</a:t>
             </a:r>
           </a:p>
           <a:p>

</xml_diff>

<commit_message>
Two names in the board universe belonged to other companies
MLCF carried a textile mill's label, and the key MFL — which is Matco Foods
on the board — carried Millat Tractors', so the engine priced one company
under another company's name and sent that name to the broker. Millat now
sits on its own ticker, MLCF is labelled as the cement maker the exchange
lists, and FFBL leaves the universe: it has no board row and no series since
merging into FFC, so it could only ever report "no history".
</commit_message>
<xml_diff>
--- a/docs/investors/KAIROS_Investor_Deck.pptx
+++ b/docs/investors/KAIROS_Investor_Deck.pptx
@@ -4710,7 +4710,7 @@
                 <a:latin typeface="Consolas"/>
                 <a:ea typeface="Consolas"/>
               </a:rPr>
-              <a:t>python -m pytest tests -q        # 947 tests</a:t>
+              <a:t>python -m pytest tests -q        # 949 tests</a:t>
             </a:r>
           </a:p>
           <a:p>
@@ -5789,7 +5789,7 @@
                 <a:latin typeface="Consolas"/>
                 <a:ea typeface="Consolas"/>
               </a:rPr>
-              <a:t>18,549</a:t>
+              <a:t>18,550</a:t>
             </a:r>
           </a:p>
           <a:p>
@@ -6053,7 +6053,7 @@
                 <a:latin typeface="Consolas"/>
                 <a:ea typeface="Consolas"/>
               </a:rPr>
-              <a:t>947</a:t>
+              <a:t>949</a:t>
             </a:r>
           </a:p>
           <a:p>
@@ -8610,7 +8610,7 @@
                 <a:latin typeface="Segoe UI"/>
                 <a:ea typeface="Segoe UI"/>
               </a:rPr>
-              <a:t>A public repository: 18,549 lines of Python, 45 modules, 947 passing tests, MIT.</a:t>
+              <a:t>A public repository: 18,550 lines of Python, 45 modules, 949 passing tests, MIT.</a:t>
             </a:r>
           </a:p>
           <a:p>

</xml_diff>

<commit_message>
The registry of scan-admitted names could be truncated into silence
psx_registered.json is the only memory of a ticker a live scan admitted, and
it was written with a plain write_text: a crash or a full disk left half a
file behind, the next boot read it as "nothing was ever admitted", and a held
line in that scrip had no instrument to price it — so the desk could neither
value nor exit it. It now goes through the atomic writer every other record
file uses.
</commit_message>
<xml_diff>
--- a/docs/investors/KAIROS_Investor_Deck.pptx
+++ b/docs/investors/KAIROS_Investor_Deck.pptx
@@ -4710,7 +4710,7 @@
                 <a:latin typeface="Consolas"/>
                 <a:ea typeface="Consolas"/>
               </a:rPr>
-              <a:t>python -m pytest tests -q        # 949 tests</a:t>
+              <a:t>python -m pytest tests -q        # 950 tests</a:t>
             </a:r>
           </a:p>
           <a:p>
@@ -5789,7 +5789,7 @@
                 <a:latin typeface="Consolas"/>
                 <a:ea typeface="Consolas"/>
               </a:rPr>
-              <a:t>18,550</a:t>
+              <a:t>18,557</a:t>
             </a:r>
           </a:p>
           <a:p>
@@ -6053,7 +6053,7 @@
                 <a:latin typeface="Consolas"/>
                 <a:ea typeface="Consolas"/>
               </a:rPr>
-              <a:t>949</a:t>
+              <a:t>950</a:t>
             </a:r>
           </a:p>
           <a:p>
@@ -8610,7 +8610,7 @@
                 <a:latin typeface="Segoe UI"/>
                 <a:ea typeface="Segoe UI"/>
               </a:rPr>
-              <a:t>A public repository: 18,550 lines of Python, 45 modules, 949 passing tests, MIT.</a:t>
+              <a:t>A public repository: 18,557 lines of Python, 45 modules, 950 passing tests, MIT.</a:t>
             </a:r>
           </a:p>
           <a:p>

</xml_diff>

<commit_message>
The ledger promised a hit rate on a Sunday that never prints a bar
`_pending_calls` dated the queue's first resolution as `ts + horizon days`
and published 2026-10-25 — a Sunday — while `feedback.resolve_outcomes`
waits for five *bars* and a five-day tape prints none at the weekend. A
reader was told to come back on a day nothing could possibly have
resolved. The bound now counts sessions on five-day tapes and calendar
days only where the instrument's own bars show weekend prints, and the
queue names the instruments behind its 1,907 rows: the desk snapshots the
same tape every ten minutes, so a four-digit call count can rest on a
dozen correlated names.

Also refreshes the pack (960 tests, 4,682 journaled, 493 cycles).
</commit_message>
<xml_diff>
--- a/docs/investors/KAIROS_Investor_Deck.pptx
+++ b/docs/investors/KAIROS_Investor_Deck.pptx
@@ -4710,7 +4710,7 @@
                 <a:latin typeface="Consolas"/>
                 <a:ea typeface="Consolas"/>
               </a:rPr>
-              <a:t>python -m pytest tests -q        # 958 tests</a:t>
+              <a:t>python -m pytest tests -q        # 960 tests</a:t>
             </a:r>
           </a:p>
           <a:p>
@@ -6053,7 +6053,7 @@
                 <a:latin typeface="Consolas"/>
                 <a:ea typeface="Consolas"/>
               </a:rPr>
-              <a:t>958</a:t>
+              <a:t>960</a:t>
             </a:r>
           </a:p>
           <a:p>
@@ -8610,7 +8610,7 @@
                 <a:latin typeface="Segoe UI"/>
                 <a:ea typeface="Segoe UI"/>
               </a:rPr>
-              <a:t>A public repository: 18,618 lines of Python, 45 modules, 958 passing tests, MIT.</a:t>
+              <a:t>A public repository: 18,618 lines of Python, 45 modules, 960 passing tests, MIT.</a:t>
             </a:r>
           </a:p>
           <a:p>

</xml_diff>

<commit_message>
A macro panel held for the daemon's life sized every later trade at boot
The intermarket panel and the cross-sectional factor row were each computed
once and then reused until the process died: nothing in the autopilot ever
asked for a refresh, so after a day the macro multiplier and the factor rows
the strategy library read came from a boot-time snapshot. Both now expire on
the 300s clock their source data already uses, a failed refresh raises and
keeps the last good panel for the next attempt, and `scan()` stamps the same
factor clock so the next prediction does not re-scan the exchange. The WSL
forecast cache, content-addressed but unbounded, is now capped like the
battery cache. Each cycle also records `last_stages` (news/predict) beside
`last_cycle_s`: a warm cycle measured 21.0s against 161.7s cold, which is what
the stage split is there to keep visible.
</commit_message>
<xml_diff>
--- a/docs/investors/KAIROS_Investor_Deck.pptx
+++ b/docs/investors/KAIROS_Investor_Deck.pptx
@@ -4710,7 +4710,7 @@
                 <a:latin typeface="Consolas"/>
                 <a:ea typeface="Consolas"/>
               </a:rPr>
-              <a:t>python -m pytest tests -q        # 982 tests</a:t>
+              <a:t>python -m pytest tests -q        # 988 tests</a:t>
             </a:r>
           </a:p>
           <a:p>
@@ -5789,7 +5789,7 @@
                 <a:latin typeface="Consolas"/>
                 <a:ea typeface="Consolas"/>
               </a:rPr>
-              <a:t>18,846</a:t>
+              <a:t>18,888</a:t>
             </a:r>
           </a:p>
           <a:p>
@@ -6053,7 +6053,7 @@
                 <a:latin typeface="Consolas"/>
                 <a:ea typeface="Consolas"/>
               </a:rPr>
-              <a:t>982</a:t>
+              <a:t>988</a:t>
             </a:r>
           </a:p>
           <a:p>
@@ -8610,7 +8610,7 @@
                 <a:latin typeface="Segoe UI"/>
                 <a:ea typeface="Segoe UI"/>
               </a:rPr>
-              <a:t>A public repository: 18,846 lines of Python, 45 modules, 982 passing tests, MIT.</a:t>
+              <a:t>A public repository: 18,888 lines of Python, 45 modules, 988 passing tests, MIT.</a:t>
             </a:r>
           </a:p>
           <a:p>

</xml_diff>

<commit_message>
A resting JS Global sell was booked as a completed close
An accepted LIMIT is not a fill. The cycle booked the exit anyway: the stop,
target and entry date were dropped while the venue still held the shares, the
untaken loss went into the cooldown counter, and the next cycle could offer the
same quantity again. `PLACED` now leaves the position managed as EXIT-WORKING,
the resting quantity blocks a duplicate offer, and reconciliation is what
forgets the entry once the venue reports itself flat.
</commit_message>
<xml_diff>
--- a/docs/investors/KAIROS_Investor_Deck.pptx
+++ b/docs/investors/KAIROS_Investor_Deck.pptx
@@ -4710,7 +4710,7 @@
                 <a:latin typeface="Consolas"/>
                 <a:ea typeface="Consolas"/>
               </a:rPr>
-              <a:t>python -m pytest tests -q        # 993 tests</a:t>
+              <a:t>python -m pytest tests -q        # 997 tests</a:t>
             </a:r>
           </a:p>
           <a:p>
@@ -5789,7 +5789,7 @@
                 <a:latin typeface="Consolas"/>
                 <a:ea typeface="Consolas"/>
               </a:rPr>
-              <a:t>18,982</a:t>
+              <a:t>19,010</a:t>
             </a:r>
           </a:p>
           <a:p>
@@ -6053,7 +6053,7 @@
                 <a:latin typeface="Consolas"/>
                 <a:ea typeface="Consolas"/>
               </a:rPr>
-              <a:t>993</a:t>
+              <a:t>997</a:t>
             </a:r>
           </a:p>
           <a:p>
@@ -8610,7 +8610,7 @@
                 <a:latin typeface="Segoe UI"/>
                 <a:ea typeface="Segoe UI"/>
               </a:rPr>
-              <a:t>A public repository: 18,982 lines of Python, 45 modules, 993 passing tests, MIT.</a:t>
+              <a:t>A public repository: 19,010 lines of Python, 45 modules, 997 passing tests, MIT.</a:t>
             </a:r>
           </a:p>
           <a:p>

</xml_diff>

<commit_message>
An MT5 exit closed every ticket in the symbol, managed or not
The exit path sent a fresh opposite DEAL — which on a hedging account opens a
second position rather than closing the first — then walked the terminal's
position list flattening every ticket that matched the symbol. So one exit paid
two spreads and liquidated trades the autopilot never managed, including the
operator's own manual ticket.

The managed ticket is already on the venue row the cycle reads, so an exit now
goes straight to close_position(ticket): one request, one ticket, one spread.
With no ticket there is nothing safe to close, so the cycle sends nothing and
keeps the position under management instead of guessing.
</commit_message>
<xml_diff>
--- a/docs/investors/KAIROS_Investor_Deck.pptx
+++ b/docs/investors/KAIROS_Investor_Deck.pptx
@@ -4710,7 +4710,7 @@
                 <a:latin typeface="Consolas"/>
                 <a:ea typeface="Consolas"/>
               </a:rPr>
-              <a:t>python -m pytest tests -q        # 997 tests</a:t>
+              <a:t>python -m pytest tests -q        # 1001 tests</a:t>
             </a:r>
           </a:p>
           <a:p>
@@ -5789,7 +5789,7 @@
                 <a:latin typeface="Consolas"/>
                 <a:ea typeface="Consolas"/>
               </a:rPr>
-              <a:t>19,010</a:t>
+              <a:t>19,004</a:t>
             </a:r>
           </a:p>
           <a:p>
@@ -6053,7 +6053,7 @@
                 <a:latin typeface="Consolas"/>
                 <a:ea typeface="Consolas"/>
               </a:rPr>
-              <a:t>997</a:t>
+              <a:t>1001</a:t>
             </a:r>
           </a:p>
           <a:p>
@@ -8610,7 +8610,7 @@
                 <a:latin typeface="Segoe UI"/>
                 <a:ea typeface="Segoe UI"/>
               </a:rPr>
-              <a:t>A public repository: 19,010 lines of Python, 45 modules, 997 passing tests, MIT.</a:t>
+              <a:t>A public repository: 19,004 lines of Python, 45 modules, 1001 passing tests, MIT.</a:t>
             </a:r>
           </a:p>
           <a:p>

</xml_diff>

<commit_message>
A Binance order that struck nothing was booked as a trade
Spot answers a MARKET order with executedQty, and an order that meets
no liquidity comes back with 0.0 on it. The bridge had been falling
back to the quantity that was asked for, so the emptiest possible
answer looked like a complete fill — and the autopilot booked an open
on a trade that never existed, or a close on a position the venue still
holds. Same in the price: a spot order response names no fills array at
all, only the quote value spent, and reading that as price 0.0 put every
live Binance trade in the audit trail as a free trade.

Now the Fill carries what actually left the venue, and an answer with
nothing executed is classified LIVE-EMPTY, journaled, and kept out of
both the held book and the entry confirmation.
</commit_message>
<xml_diff>
--- a/docs/investors/KAIROS_Investor_Deck.pptx
+++ b/docs/investors/KAIROS_Investor_Deck.pptx
@@ -4710,7 +4710,7 @@
                 <a:latin typeface="Consolas"/>
                 <a:ea typeface="Consolas"/>
               </a:rPr>
-              <a:t>python -m pytest tests -q        # 1009 tests</a:t>
+              <a:t>python -m pytest tests -q        # 1014 tests</a:t>
             </a:r>
           </a:p>
           <a:p>
@@ -5789,7 +5789,7 @@
                 <a:latin typeface="Consolas"/>
                 <a:ea typeface="Consolas"/>
               </a:rPr>
-              <a:t>19,034</a:t>
+              <a:t>19,054</a:t>
             </a:r>
           </a:p>
           <a:p>
@@ -6053,7 +6053,7 @@
                 <a:latin typeface="Consolas"/>
                 <a:ea typeface="Consolas"/>
               </a:rPr>
-              <a:t>1009</a:t>
+              <a:t>1014</a:t>
             </a:r>
           </a:p>
           <a:p>
@@ -8610,7 +8610,7 @@
                 <a:latin typeface="Segoe UI"/>
                 <a:ea typeface="Segoe UI"/>
               </a:rPr>
-              <a:t>A public repository: 19,034 lines of Python, 45 modules, 1009 passing tests, MIT.</a:t>
+              <a:t>A public repository: 19,054 lines of Python, 45 modules, 1014 passing tests, MIT.</a:t>
             </a:r>
           </a:p>
           <a:p>

</xml_diff>

<commit_message>
A close that struck part of the position was booked as a whole close
DONE_PARTIAL is an accepted MT5 order, and its entire message is that less
volume traded than was asked for. The bridge built the fill at the volume
from the request, so a partial entry was booked, journaled and displayed
at a size no venue traded — and the same lie travelled onward, because the
autopilot sizes its managed row from the order rather than the fill.

On the exit it is worse than a wrong number. A Binance close that struck
0.2 of 0.5 came back as LIVE-FILLED, so the loop realised the P&L of a
position that had not closed and dropped the row every exit is read from:
the remaining 0.3 stayed on the venue with no stop, no target and no
maturity date. The order path now reports what the venue struck, a partial
close books only the part that traded and keeps the rest managed, and a
partial entry is booked at the size that traded.
</commit_message>
<xml_diff>
--- a/docs/investors/KAIROS_Investor_Deck.pptx
+++ b/docs/investors/KAIROS_Investor_Deck.pptx
@@ -4710,7 +4710,7 @@
                 <a:latin typeface="Consolas"/>
                 <a:ea typeface="Consolas"/>
               </a:rPr>
-              <a:t>python -m pytest tests -q        # 1014 tests</a:t>
+              <a:t>python -m pytest tests -q        # 1022 tests</a:t>
             </a:r>
           </a:p>
           <a:p>
@@ -5789,7 +5789,7 @@
                 <a:latin typeface="Consolas"/>
                 <a:ea typeface="Consolas"/>
               </a:rPr>
-              <a:t>19,054</a:t>
+              <a:t>19,124</a:t>
             </a:r>
           </a:p>
           <a:p>
@@ -6053,7 +6053,7 @@
                 <a:latin typeface="Consolas"/>
                 <a:ea typeface="Consolas"/>
               </a:rPr>
-              <a:t>1014</a:t>
+              <a:t>1022</a:t>
             </a:r>
           </a:p>
           <a:p>
@@ -8610,7 +8610,7 @@
                 <a:latin typeface="Segoe UI"/>
                 <a:ea typeface="Segoe UI"/>
               </a:rPr>
-              <a:t>A public repository: 19,054 lines of Python, 45 modules, 1014 passing tests, MIT.</a:t>
+              <a:t>A public repository: 19,124 lines of Python, 45 modules, 1022 passing tests, MIT.</a:t>
             </a:r>
           </a:p>
           <a:p>

</xml_diff>

<commit_message>
A crypto order sized in MT5 lots was a hundred times too small
</commit_message>
<xml_diff>
--- a/docs/investors/KAIROS_Investor_Deck.pptx
+++ b/docs/investors/KAIROS_Investor_Deck.pptx
@@ -4710,7 +4710,7 @@
                 <a:latin typeface="Consolas"/>
                 <a:ea typeface="Consolas"/>
               </a:rPr>
-              <a:t>python -m pytest tests -q        # 1022 tests</a:t>
+              <a:t>python -m pytest tests -q        # 1026 tests</a:t>
             </a:r>
           </a:p>
           <a:p>
@@ -5789,7 +5789,7 @@
                 <a:latin typeface="Consolas"/>
                 <a:ea typeface="Consolas"/>
               </a:rPr>
-              <a:t>19,124</a:t>
+              <a:t>19,143</a:t>
             </a:r>
           </a:p>
           <a:p>
@@ -6053,7 +6053,7 @@
                 <a:latin typeface="Consolas"/>
                 <a:ea typeface="Consolas"/>
               </a:rPr>
-              <a:t>1022</a:t>
+              <a:t>1026</a:t>
             </a:r>
           </a:p>
           <a:p>
@@ -8610,7 +8610,7 @@
                 <a:latin typeface="Segoe UI"/>
                 <a:ea typeface="Segoe UI"/>
               </a:rPr>
-              <a:t>A public repository: 19,124 lines of Python, 45 modules, 1022 passing tests, MIT.</a:t>
+              <a:t>A public repository: 19,143 lines of Python, 45 modules, 1026 passing tests, MIT.</a:t>
             </a:r>
           </a:p>
           <a:p>

</xml_diff>

<commit_message>
A lot floor invented in the code rounded orders past the risk cap
The CFD size assumed a hundred-unit lot with a 0.01 floor and rounded up to
it, so a cap that could not fit the minimum placed an order the risk layer
never approved. The terminal now reports the contract size, minimum and step
per symbol, the size floors to them, and a name whose minimum exceeds the
cap is a MIN-LOT veto instead of a trade.
</commit_message>
<xml_diff>
--- a/docs/investors/KAIROS_Investor_Deck.pptx
+++ b/docs/investors/KAIROS_Investor_Deck.pptx
@@ -4710,7 +4710,7 @@
                 <a:latin typeface="Consolas"/>
                 <a:ea typeface="Consolas"/>
               </a:rPr>
-              <a:t>python -m pytest tests -q        # 1026 tests</a:t>
+              <a:t>python -m pytest tests -q        # 1035 tests</a:t>
             </a:r>
           </a:p>
           <a:p>
@@ -5789,7 +5789,7 @@
                 <a:latin typeface="Consolas"/>
                 <a:ea typeface="Consolas"/>
               </a:rPr>
-              <a:t>19,143</a:t>
+              <a:t>19,202</a:t>
             </a:r>
           </a:p>
           <a:p>
@@ -6053,7 +6053,7 @@
                 <a:latin typeface="Consolas"/>
                 <a:ea typeface="Consolas"/>
               </a:rPr>
-              <a:t>1026</a:t>
+              <a:t>1035</a:t>
             </a:r>
           </a:p>
           <a:p>
@@ -8610,7 +8610,7 @@
                 <a:latin typeface="Segoe UI"/>
                 <a:ea typeface="Segoe UI"/>
               </a:rPr>
-              <a:t>A public repository: 19,143 lines of Python, 45 modules, 1026 passing tests, MIT.</a:t>
+              <a:t>A public repository: 19,202 lines of Python, 45 modules, 1035 passing tests, MIT.</a:t>
             </a:r>
           </a:p>
           <a:p>

</xml_diff>

<commit_message>
An order off the exchange's own precision ladder was refused, and filed as an outage
Binance sizes and prices every pair by its own filters. Nothing in the bridge
consulted them, so a spot order went out with whatever decimals notional/price
happened to produce and was declined before it could trade - and every such
decline landed in the journal as UNCONFIRMED, indistinguishable from the venue
being down. The bridge now reads exchangeInfo per pair, truncates the quantity
onto its step, puts the price on its tick (down for a buy, up for a sell, never
past what was approved), refuses a size the venue cannot fill instead of sending
a no-order, and separates a 4xx decline from an unknown outcome by the status
code that decided it.
</commit_message>
<xml_diff>
--- a/docs/investors/KAIROS_Investor_Deck.pptx
+++ b/docs/investors/KAIROS_Investor_Deck.pptx
@@ -4710,7 +4710,7 @@
                 <a:latin typeface="Consolas"/>
                 <a:ea typeface="Consolas"/>
               </a:rPr>
-              <a:t>python -m pytest tests -q        # 1035 tests</a:t>
+              <a:t>python -m pytest tests -q        # 1051 tests</a:t>
             </a:r>
           </a:p>
           <a:p>
@@ -5789,7 +5789,7 @@
                 <a:latin typeface="Consolas"/>
                 <a:ea typeface="Consolas"/>
               </a:rPr>
-              <a:t>19,202</a:t>
+              <a:t>19,326</a:t>
             </a:r>
           </a:p>
           <a:p>
@@ -6053,7 +6053,7 @@
                 <a:latin typeface="Consolas"/>
                 <a:ea typeface="Consolas"/>
               </a:rPr>
-              <a:t>1035</a:t>
+              <a:t>1051</a:t>
             </a:r>
           </a:p>
           <a:p>
@@ -8610,7 +8610,7 @@
                 <a:latin typeface="Segoe UI"/>
                 <a:ea typeface="Segoe UI"/>
               </a:rPr>
-              <a:t>A public repository: 19,202 lines of Python, 45 modules, 1035 passing tests, MIT.</a:t>
+              <a:t>A public repository: 19,326 lines of Python, 45 modules, 1051 passing tests, MIT.</a:t>
             </a:r>
           </a:p>
           <a:p>

</xml_diff>

<commit_message>
The loop sized crypto on arithmetic and let the exchange tell it no
Sizing knew the cap and the price and nothing else: a spot size was
notional/price, whatever decimals that produced. The bridge had just learned
the pair's own ladder, so an untradeable call now spent a signed request to be
refused by a venue whose rules the desk could have read first. The loop asks
the venue for the same settings, floors the size onto them, and vetoes a name
whose cap cannot clear its minimum quantity or minimum order value. Rounding
the size to four decimals on the way to the venue also lifted a five-decimal
ladder back above the approved cap, so the intent now carries eight.
</commit_message>
<xml_diff>
--- a/docs/investors/KAIROS_Investor_Deck.pptx
+++ b/docs/investors/KAIROS_Investor_Deck.pptx
@@ -320,7 +320,7 @@
                 <a:latin typeface="Segoe UI"/>
                 <a:ea typeface="Segoe UI"/>
               </a:rPr>
-              <a:t>KAIROS v2.6.2 · 2026-10-24 · github.com/zhaider5142009-oss/kairos</a:t>
+              <a:t>KAIROS v2.6.2 · 2026-10-25 · github.com/zhaider5142009-oss/kairos</a:t>
             </a:r>
           </a:p>
         </p:txBody>
@@ -4710,7 +4710,7 @@
                 <a:latin typeface="Consolas"/>
                 <a:ea typeface="Consolas"/>
               </a:rPr>
-              <a:t>python -m pytest tests -q        # 1051 tests</a:t>
+              <a:t>python -m pytest tests -q        # 1057 tests</a:t>
             </a:r>
           </a:p>
           <a:p>
@@ -5789,7 +5789,7 @@
                 <a:latin typeface="Consolas"/>
                 <a:ea typeface="Consolas"/>
               </a:rPr>
-              <a:t>19,326</a:t>
+              <a:t>19,357</a:t>
             </a:r>
           </a:p>
           <a:p>
@@ -6053,7 +6053,7 @@
                 <a:latin typeface="Consolas"/>
                 <a:ea typeface="Consolas"/>
               </a:rPr>
-              <a:t>1051</a:t>
+              <a:t>1057</a:t>
             </a:r>
           </a:p>
           <a:p>
@@ -6278,7 +6278,7 @@
                 <a:latin typeface="Consolas"/>
                 <a:ea typeface="Consolas"/>
               </a:rPr>
-              <a:t>figures verified against the repository on 2026-10-24</a:t>
+              <a:t>figures verified against the repository on 2026-10-25</a:t>
             </a:r>
           </a:p>
         </p:txBody>
@@ -8610,7 +8610,7 @@
                 <a:latin typeface="Segoe UI"/>
                 <a:ea typeface="Segoe UI"/>
               </a:rPr>
-              <a:t>A public repository: 19,326 lines of Python, 45 modules, 1051 passing tests, MIT.</a:t>
+              <a:t>A public repository: 19,357 lines of Python, 45 modules, 1057 passing tests, MIT.</a:t>
             </a:r>
           </a:p>
           <a:p>

</xml_diff>

<commit_message>
A terminal that would not name the lot sized the trade at an assumed hundred units
The MT5 bridge sends the size it is handed as the order's volume, so nothing
downstream could catch the fallback: a 1,000-unit lot and a silent
symbol_info together put ten times the approved notional on the market. An
unreadable lot is now a veto, named as the terminal's silence rather than as a
cap the name failed.
</commit_message>
<xml_diff>
--- a/docs/investors/KAIROS_Investor_Deck.pptx
+++ b/docs/investors/KAIROS_Investor_Deck.pptx
@@ -4710,7 +4710,7 @@
                 <a:latin typeface="Consolas"/>
                 <a:ea typeface="Consolas"/>
               </a:rPr>
-              <a:t>python -m pytest tests -q        # 1057 tests</a:t>
+              <a:t>python -m pytest tests -q        # 1059 tests</a:t>
             </a:r>
           </a:p>
           <a:p>
@@ -5789,7 +5789,7 @@
                 <a:latin typeface="Consolas"/>
                 <a:ea typeface="Consolas"/>
               </a:rPr>
-              <a:t>19,357</a:t>
+              <a:t>19,373</a:t>
             </a:r>
           </a:p>
           <a:p>
@@ -6053,7 +6053,7 @@
                 <a:latin typeface="Consolas"/>
                 <a:ea typeface="Consolas"/>
               </a:rPr>
-              <a:t>1057</a:t>
+              <a:t>1059</a:t>
             </a:r>
           </a:p>
           <a:p>
@@ -8610,7 +8610,7 @@
                 <a:latin typeface="Segoe UI"/>
                 <a:ea typeface="Segoe UI"/>
               </a:rPr>
-              <a:t>A public repository: 19,357 lines of Python, 45 modules, 1057 passing tests, MIT.</a:t>
+              <a:t>A public repository: 19,373 lines of Python, 45 modules, 1059 passing tests, MIT.</a:t>
             </a:r>
           </a:p>
           <a:p>

</xml_diff>

<commit_message>
One merged total sized every venue's order, whatever currency it was holding
The live loop read a single account snapshot and sized from it, and with two
venues live that snapshot is MT5's USD equity added to the portal's PKR book.
As an upper bound for the breakers that overstatement errs toward refusing; as a
sizing base it does the opposite. 15% of 1,100,000 spent at a dollar price is
about eleven times the CFD the dollar account approved, and read from the PSX
side it spends dollars as if they were rupees.

Each venue's own account is now collected once per cycle and read per order;
the merged snapshot stays the desk bound. A routed venue with no account, or one
whose equity is not a usable number, is a NO-EQUITY veto rather than a silent
hold, and the desk shows the book each order was actually sized against.
</commit_message>
<xml_diff>
--- a/docs/investors/KAIROS_Investor_Deck.pptx
+++ b/docs/investors/KAIROS_Investor_Deck.pptx
@@ -4710,7 +4710,7 @@
                 <a:latin typeface="Consolas"/>
                 <a:ea typeface="Consolas"/>
               </a:rPr>
-              <a:t>python -m pytest tests -q        # 1059 tests</a:t>
+              <a:t>python -m pytest tests -q        # 1067 tests</a:t>
             </a:r>
           </a:p>
           <a:p>
@@ -5789,7 +5789,7 @@
                 <a:latin typeface="Consolas"/>
                 <a:ea typeface="Consolas"/>
               </a:rPr>
-              <a:t>19,373</a:t>
+              <a:t>19,442</a:t>
             </a:r>
           </a:p>
           <a:p>
@@ -6053,7 +6053,7 @@
                 <a:latin typeface="Consolas"/>
                 <a:ea typeface="Consolas"/>
               </a:rPr>
-              <a:t>1059</a:t>
+              <a:t>1067</a:t>
             </a:r>
           </a:p>
           <a:p>
@@ -8610,7 +8610,7 @@
                 <a:latin typeface="Segoe UI"/>
                 <a:ea typeface="Segoe UI"/>
               </a:rPr>
-              <a:t>A public repository: 19,373 lines of Python, 45 modules, 1059 passing tests, MIT.</a:t>
+              <a:t>A public repository: 19,442 lines of Python, 45 modules, 1067 passing tests, MIT.</a:t>
             </a:r>
           </a:p>
           <a:p>

</xml_diff>

<commit_message>
One blended total measured every book, so the most invested venue cleared every brake
</commit_message>
<xml_diff>
--- a/docs/investors/KAIROS_Investor_Deck.pptx
+++ b/docs/investors/KAIROS_Investor_Deck.pptx
@@ -4710,7 +4710,7 @@
                 <a:latin typeface="Consolas"/>
                 <a:ea typeface="Consolas"/>
               </a:rPr>
-              <a:t>python -m pytest tests -q        # 1067 tests</a:t>
+              <a:t>python -m pytest tests -q        # 1078 tests</a:t>
             </a:r>
           </a:p>
           <a:p>
@@ -5789,7 +5789,7 @@
                 <a:latin typeface="Consolas"/>
                 <a:ea typeface="Consolas"/>
               </a:rPr>
-              <a:t>19,442</a:t>
+              <a:t>19,514</a:t>
             </a:r>
           </a:p>
           <a:p>
@@ -6053,7 +6053,7 @@
                 <a:latin typeface="Consolas"/>
                 <a:ea typeface="Consolas"/>
               </a:rPr>
-              <a:t>1067</a:t>
+              <a:t>1078</a:t>
             </a:r>
           </a:p>
           <a:p>
@@ -8610,7 +8610,7 @@
                 <a:latin typeface="Segoe UI"/>
                 <a:ea typeface="Segoe UI"/>
               </a:rPr>
-              <a:t>A public repository: 19,442 lines of Python, 45 modules, 1067 passing tests, MIT.</a:t>
+              <a:t>A public repository: 19,514 lines of Python, 45 modules, 1078 passing tests, MIT.</a:t>
             </a:r>
           </a:p>
           <a:p>

</xml_diff>

<commit_message>
The paper book booked dollars as rupees, so the pack published −Rs 13 of a −Rs 3,501 loss
</commit_message>
<xml_diff>
--- a/docs/investors/KAIROS_Investor_Deck.pptx
+++ b/docs/investors/KAIROS_Investor_Deck.pptx
@@ -4710,7 +4710,7 @@
                 <a:latin typeface="Consolas"/>
                 <a:ea typeface="Consolas"/>
               </a:rPr>
-              <a:t>python -m pytest tests -q        # 1109 tests</a:t>
+              <a:t>python -m pytest tests -q        # 1171 tests</a:t>
             </a:r>
           </a:p>
           <a:p>
@@ -5789,7 +5789,7 @@
                 <a:latin typeface="Consolas"/>
                 <a:ea typeface="Consolas"/>
               </a:rPr>
-              <a:t>19,632</a:t>
+              <a:t>19,961</a:t>
             </a:r>
           </a:p>
           <a:p>
@@ -6053,7 +6053,7 @@
                 <a:latin typeface="Consolas"/>
                 <a:ea typeface="Consolas"/>
               </a:rPr>
-              <a:t>1109</a:t>
+              <a:t>1171</a:t>
             </a:r>
           </a:p>
           <a:p>
@@ -8610,7 +8610,7 @@
                 <a:latin typeface="Segoe UI"/>
                 <a:ea typeface="Segoe UI"/>
               </a:rPr>
-              <a:t>A public repository: 19,632 lines of Python, 45 modules, 1109 passing tests, MIT.</a:t>
+              <a:t>A public repository: 19,961 lines of Python, 45 modules, 1171 passing tests, MIT.</a:t>
             </a:r>
           </a:p>
           <a:p>
@@ -8784,7 +8784,7 @@
                 <a:latin typeface="Segoe UI"/>
                 <a:ea typeface="Segoe UI"/>
               </a:rPr>
-              <a:t>Paper book: -Rs 13.05 realized on Rs 1,000,000, 2 fills.</a:t>
+              <a:t>Paper book: −Rs 3,501.69 realized on Rs 1,000,000, 2 fills.</a:t>
             </a:r>
           </a:p>
           <a:p>

</xml_diff>

<commit_message>
A rupee label printed over a dollar book, and the guard read the same label
The track record, the pack and the desk all wrote "Rs" as a literal over
whatever amount they were handed, so a paper book funded in dollars — a
supported paper.currency — would have published dollars under a rupee label
in the one document whose job is to be checkable. The pack guard baked "Rs"
into both its pattern and its value, so it would have certified the defect.

Every surface now takes its label from money_label() in kairos/execution.py,
and the guard reads the currency from data/paper_account.json rather than
from the ledger it is checking. The sign leads the amount (−Rs 3,501.69), so
a book that turns positive restates the label instead of keeping a minus in
front of a gain.
</commit_message>
<xml_diff>
--- a/docs/investors/KAIROS_Investor_Deck.pptx
+++ b/docs/investors/KAIROS_Investor_Deck.pptx
@@ -4710,7 +4710,7 @@
                 <a:latin typeface="Consolas"/>
                 <a:ea typeface="Consolas"/>
               </a:rPr>
-              <a:t>python -m pytest tests -q        # 1171 tests</a:t>
+              <a:t>python -m pytest tests -q        # 1175 tests</a:t>
             </a:r>
           </a:p>
           <a:p>
@@ -5789,7 +5789,7 @@
                 <a:latin typeface="Consolas"/>
                 <a:ea typeface="Consolas"/>
               </a:rPr>
-              <a:t>19,961</a:t>
+              <a:t>19,982</a:t>
             </a:r>
           </a:p>
           <a:p>
@@ -6053,7 +6053,7 @@
                 <a:latin typeface="Consolas"/>
                 <a:ea typeface="Consolas"/>
               </a:rPr>
-              <a:t>1171</a:t>
+              <a:t>1175</a:t>
             </a:r>
           </a:p>
           <a:p>
@@ -8610,7 +8610,7 @@
                 <a:latin typeface="Segoe UI"/>
                 <a:ea typeface="Segoe UI"/>
               </a:rPr>
-              <a:t>A public repository: 19,961 lines of Python, 45 modules, 1171 passing tests, MIT.</a:t>
+              <a:t>A public repository: 19,982 lines of Python, 45 modules, 1175 passing tests, MIT.</a:t>
             </a:r>
           </a:p>
           <a:p>

</xml_diff>

<commit_message>
Two venue equities on one line, and only one of them said what money it was in
With both a dollar terminal and a rupee portal live, the desk printed
"sizing book MT5 100,000 · JS_GLOBAL 1,000,000" with no label on either
figure — eleven times each other if a reader guessed the wrong one. Each
venue's number now travels with the currency its own account reports, and
the desk prints a bare number only when the bridge reported none.

Adding the currency to the PSX snapshot exposed a live ordering bug in
_venue_currency: the merged snapshot was read second, so a silent MT5 was
priced in PKR off the PSX book beside it, failed to find an FX cross, and
was refused as NO-FX instead of the missing account it actually was. The
venue's own part wins, then what that venue settles in, then the snapshot.
</commit_message>
<xml_diff>
--- a/docs/investors/KAIROS_Investor_Deck.pptx
+++ b/docs/investors/KAIROS_Investor_Deck.pptx
@@ -4710,7 +4710,7 @@
                 <a:latin typeface="Consolas"/>
                 <a:ea typeface="Consolas"/>
               </a:rPr>
-              <a:t>python -m pytest tests -q        # 1175 tests</a:t>
+              <a:t>python -m pytest tests -q        # 1177 tests</a:t>
             </a:r>
           </a:p>
           <a:p>
@@ -5789,7 +5789,7 @@
                 <a:latin typeface="Consolas"/>
                 <a:ea typeface="Consolas"/>
               </a:rPr>
-              <a:t>19,982</a:t>
+              <a:t>19,998</a:t>
             </a:r>
           </a:p>
           <a:p>
@@ -6053,7 +6053,7 @@
                 <a:latin typeface="Consolas"/>
                 <a:ea typeface="Consolas"/>
               </a:rPr>
-              <a:t>1175</a:t>
+              <a:t>1177</a:t>
             </a:r>
           </a:p>
           <a:p>
@@ -8610,7 +8610,7 @@
                 <a:latin typeface="Segoe UI"/>
                 <a:ea typeface="Segoe UI"/>
               </a:rPr>
-              <a:t>A public repository: 19,982 lines of Python, 45 modules, 1175 passing tests, MIT.</a:t>
+              <a:t>A public repository: 19,998 lines of Python, 45 modules, 1177 passing tests, MIT.</a:t>
             </a:r>
           </a:p>
           <a:p>

</xml_diff>

<commit_message>
The bridge told a PMEX operator to sign in, on a machine that only ever held a demo terminal
attach() could only repeat what the IPC link said, so a blank mt5.server and a
demo-only install surfaced as "not signed in" or a bare account mismatch. The
terminal's own UTF-16 log records the broker that answered and why, and the
preflight now reads it: which installs exist, which networks they have reached,
the last refusal (account masked to three digits), and the blockers that make a
link impossible before any attach is spent.
</commit_message>
<xml_diff>
--- a/docs/investors/KAIROS_Investor_Deck.pptx
+++ b/docs/investors/KAIROS_Investor_Deck.pptx
@@ -4710,7 +4710,7 @@
                 <a:latin typeface="Consolas"/>
                 <a:ea typeface="Consolas"/>
               </a:rPr>
-              <a:t>python -m pytest tests -q        # 1177 tests</a:t>
+              <a:t>python -m pytest tests -q        # 1188 tests</a:t>
             </a:r>
           </a:p>
           <a:p>
@@ -5789,7 +5789,7 @@
                 <a:latin typeface="Consolas"/>
                 <a:ea typeface="Consolas"/>
               </a:rPr>
-              <a:t>19,998</a:t>
+              <a:t>20,194</a:t>
             </a:r>
           </a:p>
           <a:p>
@@ -6053,7 +6053,7 @@
                 <a:latin typeface="Consolas"/>
                 <a:ea typeface="Consolas"/>
               </a:rPr>
-              <a:t>1177</a:t>
+              <a:t>1188</a:t>
             </a:r>
           </a:p>
           <a:p>
@@ -8610,7 +8610,7 @@
                 <a:latin typeface="Segoe UI"/>
                 <a:ea typeface="Segoe UI"/>
               </a:rPr>
-              <a:t>A public repository: 19,998 lines of Python, 45 modules, 1177 passing tests, MIT.</a:t>
+              <a:t>A public repository: 20,194 lines of Python, 45 modules, 1188 passing tests, MIT.</a:t>
             </a:r>
           </a:p>
           <a:p>

</xml_diff>

<commit_message>
A feed could declare the entities it expanded, and arrive with no ceiling
</commit_message>
<xml_diff>
--- a/docs/investors/KAIROS_Investor_Deck.pptx
+++ b/docs/investors/KAIROS_Investor_Deck.pptx
@@ -4710,7 +4710,7 @@
                 <a:latin typeface="Consolas"/>
                 <a:ea typeface="Consolas"/>
               </a:rPr>
-              <a:t>python -m pytest tests -q        # 1188 tests</a:t>
+              <a:t>python -m pytest tests -q        # 1193 tests</a:t>
             </a:r>
           </a:p>
           <a:p>
@@ -5789,7 +5789,7 @@
                 <a:latin typeface="Consolas"/>
                 <a:ea typeface="Consolas"/>
               </a:rPr>
-              <a:t>20,194</a:t>
+              <a:t>20,246</a:t>
             </a:r>
           </a:p>
           <a:p>
@@ -6053,7 +6053,7 @@
                 <a:latin typeface="Consolas"/>
                 <a:ea typeface="Consolas"/>
               </a:rPr>
-              <a:t>1188</a:t>
+              <a:t>1193</a:t>
             </a:r>
           </a:p>
           <a:p>
@@ -8610,7 +8610,7 @@
                 <a:latin typeface="Segoe UI"/>
                 <a:ea typeface="Segoe UI"/>
               </a:rPr>
-              <a:t>A public repository: 20,194 lines of Python, 45 modules, 1188 passing tests, MIT.</a:t>
+              <a:t>A public repository: 20,246 lines of Python, 45 modules, 1193 passing tests, MIT.</a:t>
             </a:r>
           </a:p>
           <a:p>

</xml_diff>

<commit_message>
Seven dead feeds and every empty link read as a quiet news day
The desk fetched seven RSS feeds, dropped any that failed, and returned
whatever survived; a 404 on one and an outage on the rest looked identical
to a market with nothing to say. NewsService now records, per fetch, when
it ran, how many feeds answered, and each failure by name and reason, and
/api/news publishes that block so the panel can print "N of M feeds down".

The same route read `i.url` and `i.score`, neither of which NewsItem has,
so every headline in the desk pointed at "". It now sends `i.link`, and the
Dawn Business feed URL is corrected to the one that answers (it had been
404ing).
</commit_message>
<xml_diff>
--- a/docs/investors/KAIROS_Investor_Deck.pptx
+++ b/docs/investors/KAIROS_Investor_Deck.pptx
@@ -4710,7 +4710,7 @@
                 <a:latin typeface="Consolas"/>
                 <a:ea typeface="Consolas"/>
               </a:rPr>
-              <a:t>python -m pytest tests -q        # 1193 tests</a:t>
+              <a:t>python -m pytest tests -q        # 1197 tests</a:t>
             </a:r>
           </a:p>
           <a:p>
@@ -5789,7 +5789,7 @@
                 <a:latin typeface="Consolas"/>
                 <a:ea typeface="Consolas"/>
               </a:rPr>
-              <a:t>20,246</a:t>
+              <a:t>20,271</a:t>
             </a:r>
           </a:p>
           <a:p>
@@ -6053,7 +6053,7 @@
                 <a:latin typeface="Consolas"/>
                 <a:ea typeface="Consolas"/>
               </a:rPr>
-              <a:t>1193</a:t>
+              <a:t>1197</a:t>
             </a:r>
           </a:p>
           <a:p>
@@ -8610,7 +8610,7 @@
                 <a:latin typeface="Segoe UI"/>
                 <a:ea typeface="Segoe UI"/>
               </a:rPr>
-              <a:t>A public repository: 20,246 lines of Python, 45 modules, 1193 passing tests, MIT.</a:t>
+              <a:t>A public repository: 20,271 lines of Python, 45 modules, 1197 passing tests, MIT.</a:t>
             </a:r>
           </a:p>
           <a:p>

</xml_diff>

<commit_message>
A headline's date was cut where its timezone began
Every feed item kept only the first 25 characters of its pubDate, which is
exactly one character short of "Tue, 21 Oct 2026 00:00:00 GMT". The zone
was gone, so a date from a +0500 publisher could not be ordered against a
GMT one, and the desk listed headlines feed by feed — whatever the first
host happened to send sat at the top of a panel titled "latest".

Dates are now stored whole, `news_timestamp()` reads both RFC-822 and
ISO-8601 (None, not epoch zero, when it cannot), and /api/news sorts
newest first with undated rows last. Feed attribution order inside the
fetcher is deliberately unchanged.
</commit_message>
<xml_diff>
--- a/docs/investors/KAIROS_Investor_Deck.pptx
+++ b/docs/investors/KAIROS_Investor_Deck.pptx
@@ -4710,7 +4710,7 @@
                 <a:latin typeface="Consolas"/>
                 <a:ea typeface="Consolas"/>
               </a:rPr>
-              <a:t>python -m pytest tests -q        # 1197 tests</a:t>
+              <a:t>python -m pytest tests -q        # 1200 tests</a:t>
             </a:r>
           </a:p>
           <a:p>
@@ -5789,7 +5789,7 @@
                 <a:latin typeface="Consolas"/>
                 <a:ea typeface="Consolas"/>
               </a:rPr>
-              <a:t>20,271</a:t>
+              <a:t>20,312</a:t>
             </a:r>
           </a:p>
           <a:p>
@@ -6053,7 +6053,7 @@
                 <a:latin typeface="Consolas"/>
                 <a:ea typeface="Consolas"/>
               </a:rPr>
-              <a:t>1197</a:t>
+              <a:t>1200</a:t>
             </a:r>
           </a:p>
           <a:p>
@@ -8610,7 +8610,7 @@
                 <a:latin typeface="Segoe UI"/>
                 <a:ea typeface="Segoe UI"/>
               </a:rPr>
-              <a:t>A public repository: 20,271 lines of Python, 45 modules, 1197 passing tests, MIT.</a:t>
+              <a:t>A public repository: 20,312 lines of Python, 45 modules, 1200 passing tests, MIT.</a:t>
             </a:r>
           </a:p>
           <a:p>

</xml_diff>

<commit_message>
The cash fell by the trade and by the rupee, and only cash knew both
The paper book's two closed trades lost Rs 3,501.69 on the price and another
Rs 2,760.38 on the cross between their entry and exit, because a dollar leg is
converted twice. Only `cash` carried both, so the account published equity down
Rs 6,262.07 beside a `realized P&L` of 3,501.69 and nothing in between. The
translation is now its own realised line, booked against the cross the open lot
was carried at, persisted with the ledger and printed beside the total it makes
up. A ticket that crosses zero also stops carrying the closed side's basis into
the new lot.
</commit_message>
<xml_diff>
--- a/docs/investors/KAIROS_Investor_Deck.pptx
+++ b/docs/investors/KAIROS_Investor_Deck.pptx
@@ -4710,7 +4710,7 @@
                 <a:latin typeface="Consolas"/>
                 <a:ea typeface="Consolas"/>
               </a:rPr>
-              <a:t>python -m pytest tests -q        # 1200 tests</a:t>
+              <a:t>python -m pytest tests -q        # 1207 tests</a:t>
             </a:r>
           </a:p>
           <a:p>
@@ -5789,7 +5789,7 @@
                 <a:latin typeface="Consolas"/>
                 <a:ea typeface="Consolas"/>
               </a:rPr>
-              <a:t>20,312</a:t>
+              <a:t>20,352</a:t>
             </a:r>
           </a:p>
           <a:p>
@@ -6053,7 +6053,7 @@
                 <a:latin typeface="Consolas"/>
                 <a:ea typeface="Consolas"/>
               </a:rPr>
-              <a:t>1200</a:t>
+              <a:t>1207</a:t>
             </a:r>
           </a:p>
           <a:p>
@@ -8610,7 +8610,7 @@
                 <a:latin typeface="Segoe UI"/>
                 <a:ea typeface="Segoe UI"/>
               </a:rPr>
-              <a:t>A public repository: 20,312 lines of Python, 45 modules, 1200 passing tests, MIT.</a:t>
+              <a:t>A public repository: 20,352 lines of Python, 45 modules, 1207 passing tests, MIT.</a:t>
             </a:r>
           </a:p>
           <a:p>

</xml_diff>

<commit_message>
The desk posture showed a realized figure that could not explain its own equity
</commit_message>
<xml_diff>
--- a/docs/investors/KAIROS_Investor_Deck.pptx
+++ b/docs/investors/KAIROS_Investor_Deck.pptx
@@ -4710,7 +4710,7 @@
                 <a:latin typeface="Consolas"/>
                 <a:ea typeface="Consolas"/>
               </a:rPr>
-              <a:t>python -m pytest tests -q        # 1207 tests</a:t>
+              <a:t>python -m pytest tests -q        # 1208 tests</a:t>
             </a:r>
           </a:p>
           <a:p>
@@ -5789,7 +5789,7 @@
                 <a:latin typeface="Consolas"/>
                 <a:ea typeface="Consolas"/>
               </a:rPr>
-              <a:t>20,352</a:t>
+              <a:t>20,363</a:t>
             </a:r>
           </a:p>
           <a:p>
@@ -6053,7 +6053,7 @@
                 <a:latin typeface="Consolas"/>
                 <a:ea typeface="Consolas"/>
               </a:rPr>
-              <a:t>1207</a:t>
+              <a:t>1208</a:t>
             </a:r>
           </a:p>
           <a:p>
@@ -8610,7 +8610,7 @@
                 <a:latin typeface="Segoe UI"/>
                 <a:ea typeface="Segoe UI"/>
               </a:rPr>
-              <a:t>A public repository: 20,352 lines of Python, 45 modules, 1207 passing tests, MIT.</a:t>
+              <a:t>A public repository: 20,363 lines of Python, 45 modules, 1208 passing tests, MIT.</a:t>
             </a:r>
           </a:p>
           <a:p>

</xml_diff>

<commit_message>
The pack published a fifth of the loss it had taken
The paper book lost Rs 3,501.69 on price and another Rs 2,760.38 on the cross
between entry and exit. The ledger printed both and their sum; the deck, the
one-pager, the whitepaper and the landing page printed only the first, so a
0.63% drawdown read as 0.35% — the smaller number, under a footer claiming the
figures were verified that day.

The translation and the total are now stamps like the realized figure beside
them: parsed from the ledger by `kit_stats.ledger()`, written by `--write`,
compared by the pack tests, and refused rather than invented on a rupee-only
book that has no translation to declare. The deck went from 1208 tests to 1209
and its slide 5 carries the same three-part sentence as the text files.
</commit_message>
<xml_diff>
--- a/docs/investors/KAIROS_Investor_Deck.pptx
+++ b/docs/investors/KAIROS_Investor_Deck.pptx
@@ -4710,7 +4710,7 @@
                 <a:latin typeface="Consolas"/>
                 <a:ea typeface="Consolas"/>
               </a:rPr>
-              <a:t>python -m pytest tests -q        # 1208 tests</a:t>
+              <a:t>python -m pytest tests -q        # 1209 tests</a:t>
             </a:r>
           </a:p>
           <a:p>
@@ -6053,7 +6053,7 @@
                 <a:latin typeface="Consolas"/>
                 <a:ea typeface="Consolas"/>
               </a:rPr>
-              <a:t>1208</a:t>
+              <a:t>1209</a:t>
             </a:r>
           </a:p>
           <a:p>
@@ -8610,7 +8610,7 @@
                 <a:latin typeface="Segoe UI"/>
                 <a:ea typeface="Segoe UI"/>
               </a:rPr>
-              <a:t>A public repository: 20,363 lines of Python, 45 modules, 1208 passing tests, MIT.</a:t>
+              <a:t>A public repository: 20,363 lines of Python, 45 modules, 1209 passing tests, MIT.</a:t>
             </a:r>
           </a:p>
           <a:p>
@@ -8784,7 +8784,7 @@
                 <a:latin typeface="Segoe UI"/>
                 <a:ea typeface="Segoe UI"/>
               </a:rPr>
-              <a:t>Paper book: −Rs 3,501.69 realized on Rs 1,000,000, 2 fills.</a:t>
+              <a:t>Paper book: −Rs 3,501.69 trading P&amp;L, FX translation −Rs 2,760.38, −Rs 6,262.07 in total on Rs 1,000,000, 2 fills.</a:t>
             </a:r>
           </a:p>
           <a:p>

</xml_diff>

<commit_message>
A new login was measured against the account before it
The day's opening equity and the high-water mark are facts about one account,
but both were filed under the venue. Pointing the terminal at the funded PMEX
login measured its first balance against the demo's open — a fabricated loss
that opens the brake all day, or a fabricated gain that hides the real one —
and left every entry refused until the new book outgrew a peak it never set.

Both keys now carry the account (masked to its last three digits), so a swap
starts its own day and its own peak while the same login keeps measuring.
</commit_message>
<xml_diff>
--- a/docs/investors/KAIROS_Investor_Deck.pptx
+++ b/docs/investors/KAIROS_Investor_Deck.pptx
@@ -4710,7 +4710,7 @@
                 <a:latin typeface="Consolas"/>
                 <a:ea typeface="Consolas"/>
               </a:rPr>
-              <a:t>python -m pytest tests -q        # 1222 tests</a:t>
+              <a:t>python -m pytest tests -q        # 1224 tests</a:t>
             </a:r>
           </a:p>
           <a:p>
@@ -5789,7 +5789,7 @@
                 <a:latin typeface="Consolas"/>
                 <a:ea typeface="Consolas"/>
               </a:rPr>
-              <a:t>20,466</a:t>
+              <a:t>20,501</a:t>
             </a:r>
           </a:p>
           <a:p>
@@ -6053,7 +6053,7 @@
                 <a:latin typeface="Consolas"/>
                 <a:ea typeface="Consolas"/>
               </a:rPr>
-              <a:t>1222</a:t>
+              <a:t>1224</a:t>
             </a:r>
           </a:p>
           <a:p>
@@ -8610,7 +8610,7 @@
                 <a:latin typeface="Segoe UI"/>
                 <a:ea typeface="Segoe UI"/>
               </a:rPr>
-              <a:t>A public repository: 20,466 lines of Python, 45 modules, 1222 passing tests, MIT.</a:t>
+              <a:t>A public repository: 20,501 lines of Python, 45 modules, 1224 passing tests, MIT.</a:t>
             </a:r>
           </a:p>
           <a:p>

</xml_diff>

<commit_message>
`status` raised on the one book it exists to explain
`acct.get('equity', 0)` hands back a stored None rather than the default, so the
format spec raised TypeError in the middle of `kairos autopilot status` exactly
when a holding could not be marked — the moment an operator runs it. The command
and the live-book panel now print "unreadable", the word the API already uses,
instead of a crash or a green dash over a day nobody measured.
</commit_message>
<xml_diff>
--- a/docs/investors/KAIROS_Investor_Deck.pptx
+++ b/docs/investors/KAIROS_Investor_Deck.pptx
@@ -4710,7 +4710,7 @@
                 <a:latin typeface="Consolas"/>
                 <a:ea typeface="Consolas"/>
               </a:rPr>
-              <a:t>python -m pytest tests -q        # 1229 tests</a:t>
+              <a:t>python -m pytest tests -q        # 1231 tests</a:t>
             </a:r>
           </a:p>
           <a:p>
@@ -5789,7 +5789,7 @@
                 <a:latin typeface="Consolas"/>
                 <a:ea typeface="Consolas"/>
               </a:rPr>
-              <a:t>20,535</a:t>
+              <a:t>20,542</a:t>
             </a:r>
           </a:p>
           <a:p>
@@ -6053,7 +6053,7 @@
                 <a:latin typeface="Consolas"/>
                 <a:ea typeface="Consolas"/>
               </a:rPr>
-              <a:t>1229</a:t>
+              <a:t>1231</a:t>
             </a:r>
           </a:p>
           <a:p>
@@ -8610,7 +8610,7 @@
                 <a:latin typeface="Segoe UI"/>
                 <a:ea typeface="Segoe UI"/>
               </a:rPr>
-              <a:t>A public repository: 20,535 lines of Python, 45 modules, 1229 passing tests, MIT.</a:t>
+              <a:t>A public repository: 20,542 lines of Python, 45 modules, 1231 passing tests, MIT.</a:t>
             </a:r>
           </a:p>
           <a:p>

</xml_diff>

<commit_message>
An unpriced holding printed as a flat one on all three screens
When the engine could not price a live-book name, `review()` returned a row
with no last, no P&L and no percentage — and the CLI filled them with zero, the
chat summed the book over the rows it could price and called that sum the
book's, and the desk painted the gap red. The row now carries an explicit None;
each surface says "unreadable", and a book total names how many rows it covers
or admits it is unknown.
</commit_message>
<xml_diff>
--- a/docs/investors/KAIROS_Investor_Deck.pptx
+++ b/docs/investors/KAIROS_Investor_Deck.pptx
@@ -4710,7 +4710,7 @@
                 <a:latin typeface="Consolas"/>
                 <a:ea typeface="Consolas"/>
               </a:rPr>
-              <a:t>python -m pytest tests -q        # 1231 tests</a:t>
+              <a:t>python -m pytest tests -q        # 1236 tests</a:t>
             </a:r>
           </a:p>
           <a:p>
@@ -5789,7 +5789,7 @@
                 <a:latin typeface="Consolas"/>
                 <a:ea typeface="Consolas"/>
               </a:rPr>
-              <a:t>20,542</a:t>
+              <a:t>20,578</a:t>
             </a:r>
           </a:p>
           <a:p>
@@ -6053,7 +6053,7 @@
                 <a:latin typeface="Consolas"/>
                 <a:ea typeface="Consolas"/>
               </a:rPr>
-              <a:t>1231</a:t>
+              <a:t>1236</a:t>
             </a:r>
           </a:p>
           <a:p>
@@ -8610,7 +8610,7 @@
                 <a:latin typeface="Segoe UI"/>
                 <a:ea typeface="Segoe UI"/>
               </a:rPr>
-              <a:t>A public repository: 20,542 lines of Python, 45 modules, 1231 passing tests, MIT.</a:t>
+              <a:t>A public repository: 20,578 lines of Python, 45 modules, 1236 passing tests, MIT.</a:t>
             </a:r>
           </a:p>
           <a:p>

</xml_diff>

<commit_message>
A position dropped from the watchlist kept a stop nothing was evaluating
Every exit — hard stop, target, trailing ratchet, signal flip, maturity — is
evaluated inside the per-symbol loop, which walked `st["symbols"]` alone. That
list is operator-editable: `configure(symbols=...)` replaces it wholesale and a
PSX rotation rebuilds it from the day's screener. A held name that left it kept
its stop, target and entry date unread, while the venue still held the trade,
and `_reconcile` deliberately never forgets a position the venue still reports.
Nothing else managed it, so it sat there until a human closed it — a healthy
looking desk with a stop that binds nothing.

The loop now scans the watchlist plus every held key, and a held key the
universe cannot resolve is recorded once instead of skipped in silence.
</commit_message>
<xml_diff>
--- a/docs/investors/KAIROS_Investor_Deck.pptx
+++ b/docs/investors/KAIROS_Investor_Deck.pptx
@@ -4710,7 +4710,7 @@
                 <a:latin typeface="Consolas"/>
                 <a:ea typeface="Consolas"/>
               </a:rPr>
-              <a:t>python -m pytest tests -q        # 1236 tests</a:t>
+              <a:t>python -m pytest tests -q        # 1241 tests</a:t>
             </a:r>
           </a:p>
           <a:p>
@@ -5789,7 +5789,7 @@
                 <a:latin typeface="Consolas"/>
                 <a:ea typeface="Consolas"/>
               </a:rPr>
-              <a:t>20,578</a:t>
+              <a:t>20,611</a:t>
             </a:r>
           </a:p>
           <a:p>
@@ -6053,7 +6053,7 @@
                 <a:latin typeface="Consolas"/>
                 <a:ea typeface="Consolas"/>
               </a:rPr>
-              <a:t>1236</a:t>
+              <a:t>1241</a:t>
             </a:r>
           </a:p>
           <a:p>
@@ -8610,7 +8610,7 @@
                 <a:latin typeface="Segoe UI"/>
                 <a:ea typeface="Segoe UI"/>
               </a:rPr>
-              <a:t>A public repository: 20,578 lines of Python, 45 modules, 1236 passing tests, MIT.</a:t>
+              <a:t>A public repository: 20,611 lines of Python, 45 modules, 1241 passing tests, MIT.</a:t>
             </a:r>
           </a:p>
           <a:p>

</xml_diff>

<commit_message>
A dead tunnel was still advertised as the public address
/api/health published whatever hostname the keeper last wrote, however old.
The quick tunnel had been stuck for ~18 h printing "Unauthorized: Tunnel not
found" while the file still named it, so the endpoint meant to expose rot was
serving a dead link. Health now refuses a stamp older than 10 minutes, and the
keeper re-stamps on every healthy probe and requires ok:true in the body before
it calls the tunnel live.
</commit_message>
<xml_diff>
--- a/docs/investors/KAIROS_Investor_Deck.pptx
+++ b/docs/investors/KAIROS_Investor_Deck.pptx
@@ -4710,7 +4710,7 @@
                 <a:latin typeface="Consolas"/>
                 <a:ea typeface="Consolas"/>
               </a:rPr>
-              <a:t>python -m pytest tests -q        # 1241 tests</a:t>
+              <a:t>python -m pytest tests -q        # 1245 tests</a:t>
             </a:r>
           </a:p>
           <a:p>
@@ -5789,7 +5789,7 @@
                 <a:latin typeface="Consolas"/>
                 <a:ea typeface="Consolas"/>
               </a:rPr>
-              <a:t>20,611</a:t>
+              <a:t>20,626</a:t>
             </a:r>
           </a:p>
           <a:p>
@@ -6053,7 +6053,7 @@
                 <a:latin typeface="Consolas"/>
                 <a:ea typeface="Consolas"/>
               </a:rPr>
-              <a:t>1241</a:t>
+              <a:t>1245</a:t>
             </a:r>
           </a:p>
           <a:p>
@@ -8610,7 +8610,7 @@
                 <a:latin typeface="Segoe UI"/>
                 <a:ea typeface="Segoe UI"/>
               </a:rPr>
-              <a:t>A public repository: 20,611 lines of Python, 45 modules, 1241 passing tests, MIT.</a:t>
+              <a:t>A public repository: 20,626 lines of Python, 45 modules, 1245 passing tests, MIT.</a:t>
             </a:r>
           </a:p>
           <a:p>

</xml_diff>

<commit_message>
A strategy was paid for the tape it never sat through
Skill was subtracted against the up-rate of the whole condition, so a member
that abstained whenever the tape fell collected the promotion its abstentions
spared it, and a caller that was right against its own tape was charged for the
drift it overcame. Each strategy row now carries the tape over exactly the
slices it voted on, a weight with no paired denominator is refused, and the
leaderboard prints its reference from the strategy's own long/short mix.
Artifact regenerated at schema 3 (1,028 slices, 32,349 votes, 0.71-1.26).
</commit_message>
<xml_diff>
--- a/docs/investors/KAIROS_Investor_Deck.pptx
+++ b/docs/investors/KAIROS_Investor_Deck.pptx
@@ -4710,7 +4710,7 @@
                 <a:latin typeface="Consolas"/>
                 <a:ea typeface="Consolas"/>
               </a:rPr>
-              <a:t>python -m pytest tests -q        # 1245 tests</a:t>
+              <a:t>python -m pytest tests -q        # 1247 tests</a:t>
             </a:r>
           </a:p>
           <a:p>
@@ -5789,7 +5789,7 @@
                 <a:latin typeface="Consolas"/>
                 <a:ea typeface="Consolas"/>
               </a:rPr>
-              <a:t>20,626</a:t>
+              <a:t>20,646</a:t>
             </a:r>
           </a:p>
           <a:p>
@@ -6053,7 +6053,7 @@
                 <a:latin typeface="Consolas"/>
                 <a:ea typeface="Consolas"/>
               </a:rPr>
-              <a:t>1245</a:t>
+              <a:t>1247</a:t>
             </a:r>
           </a:p>
           <a:p>
@@ -8610,7 +8610,7 @@
                 <a:latin typeface="Segoe UI"/>
                 <a:ea typeface="Segoe UI"/>
               </a:rPr>
-              <a:t>A public repository: 20,626 lines of Python, 45 modules, 1245 passing tests, MIT.</a:t>
+              <a:t>A public repository: 20,646 lines of Python, 45 modules, 1247 passing tests, MIT.</a:t>
             </a:r>
           </a:p>
           <a:p>

</xml_diff>